<commit_message>
check: round 169 passed
</commit_message>
<xml_diff>
--- a/results/cell_ppt_edited/acceptance.pptx
+++ b/results/cell_ppt_edited/acceptance.pptx
@@ -236,7 +236,7 @@
           <a:bodyPr/>
           <a:lstStyle/>
           <a:p>
-            <a:fld id="{BE8087A8-B5D7-4357-AE59-6FD17618C1CA}" type="datetimeFigureOut">
+            <a:fld id="{73E72A7C-4DEC-4564-84EC-EE042061928E}" type="datetimeFigureOut">
               <a:rPr lang="zh-CN" altLang="en-US" smtClean="0"/>
               <a:t>2026/10/2</a:t>
             </a:fld>
@@ -278,7 +278,7 @@
           <a:bodyPr/>
           <a:lstStyle/>
           <a:p>
-            <a:fld id="{BBD35C1D-5E65-4137-BC2C-8F2F549B8297}" type="slidenum">
+            <a:fld id="{DD558A60-CB82-4CF8-8E8F-98547F9B331C}" type="slidenum">
               <a:rPr lang="zh-CN" altLang="en-US" smtClean="0"/>
               <a:t>‹#›</a:t>
             </a:fld>
@@ -289,7 +289,7 @@
     </p:spTree>
     <p:extLst>
       <p:ext uri="{BB962C8B-B14F-4D97-AF65-F5344CB8AC3E}">
-        <p14:creationId xmlns:p14="http://schemas.microsoft.com/office/powerpoint/2010/main" val="2630955929"/>
+        <p14:creationId xmlns:p14="http://schemas.microsoft.com/office/powerpoint/2010/main" val="704060550"/>
       </p:ext>
     </p:extLst>
   </p:cSld>
@@ -406,7 +406,7 @@
           <a:bodyPr/>
           <a:lstStyle/>
           <a:p>
-            <a:fld id="{BE8087A8-B5D7-4357-AE59-6FD17618C1CA}" type="datetimeFigureOut">
+            <a:fld id="{73E72A7C-4DEC-4564-84EC-EE042061928E}" type="datetimeFigureOut">
               <a:rPr lang="zh-CN" altLang="en-US" smtClean="0"/>
               <a:t>2026/10/2</a:t>
             </a:fld>
@@ -448,7 +448,7 @@
           <a:bodyPr/>
           <a:lstStyle/>
           <a:p>
-            <a:fld id="{BBD35C1D-5E65-4137-BC2C-8F2F549B8297}" type="slidenum">
+            <a:fld id="{DD558A60-CB82-4CF8-8E8F-98547F9B331C}" type="slidenum">
               <a:rPr lang="zh-CN" altLang="en-US" smtClean="0"/>
               <a:t>‹#›</a:t>
             </a:fld>
@@ -459,7 +459,7 @@
     </p:spTree>
     <p:extLst>
       <p:ext uri="{BB962C8B-B14F-4D97-AF65-F5344CB8AC3E}">
-        <p14:creationId xmlns:p14="http://schemas.microsoft.com/office/powerpoint/2010/main" val="434466824"/>
+        <p14:creationId xmlns:p14="http://schemas.microsoft.com/office/powerpoint/2010/main" val="1461297895"/>
       </p:ext>
     </p:extLst>
   </p:cSld>
@@ -586,7 +586,7 @@
           <a:bodyPr/>
           <a:lstStyle/>
           <a:p>
-            <a:fld id="{BE8087A8-B5D7-4357-AE59-6FD17618C1CA}" type="datetimeFigureOut">
+            <a:fld id="{73E72A7C-4DEC-4564-84EC-EE042061928E}" type="datetimeFigureOut">
               <a:rPr lang="zh-CN" altLang="en-US" smtClean="0"/>
               <a:t>2026/10/2</a:t>
             </a:fld>
@@ -628,7 +628,7 @@
           <a:bodyPr/>
           <a:lstStyle/>
           <a:p>
-            <a:fld id="{BBD35C1D-5E65-4137-BC2C-8F2F549B8297}" type="slidenum">
+            <a:fld id="{DD558A60-CB82-4CF8-8E8F-98547F9B331C}" type="slidenum">
               <a:rPr lang="zh-CN" altLang="en-US" smtClean="0"/>
               <a:t>‹#›</a:t>
             </a:fld>
@@ -639,7 +639,7 @@
     </p:spTree>
     <p:extLst>
       <p:ext uri="{BB962C8B-B14F-4D97-AF65-F5344CB8AC3E}">
-        <p14:creationId xmlns:p14="http://schemas.microsoft.com/office/powerpoint/2010/main" val="1042765240"/>
+        <p14:creationId xmlns:p14="http://schemas.microsoft.com/office/powerpoint/2010/main" val="1980127114"/>
       </p:ext>
     </p:extLst>
   </p:cSld>
@@ -756,7 +756,7 @@
           <a:bodyPr/>
           <a:lstStyle/>
           <a:p>
-            <a:fld id="{BE8087A8-B5D7-4357-AE59-6FD17618C1CA}" type="datetimeFigureOut">
+            <a:fld id="{73E72A7C-4DEC-4564-84EC-EE042061928E}" type="datetimeFigureOut">
               <a:rPr lang="zh-CN" altLang="en-US" smtClean="0"/>
               <a:t>2026/10/2</a:t>
             </a:fld>
@@ -798,7 +798,7 @@
           <a:bodyPr/>
           <a:lstStyle/>
           <a:p>
-            <a:fld id="{BBD35C1D-5E65-4137-BC2C-8F2F549B8297}" type="slidenum">
+            <a:fld id="{DD558A60-CB82-4CF8-8E8F-98547F9B331C}" type="slidenum">
               <a:rPr lang="zh-CN" altLang="en-US" smtClean="0"/>
               <a:t>‹#›</a:t>
             </a:fld>
@@ -809,7 +809,7 @@
     </p:spTree>
     <p:extLst>
       <p:ext uri="{BB962C8B-B14F-4D97-AF65-F5344CB8AC3E}">
-        <p14:creationId xmlns:p14="http://schemas.microsoft.com/office/powerpoint/2010/main" val="1346274400"/>
+        <p14:creationId xmlns:p14="http://schemas.microsoft.com/office/powerpoint/2010/main" val="1611081952"/>
       </p:ext>
     </p:extLst>
   </p:cSld>
@@ -1002,7 +1002,7 @@
           <a:bodyPr/>
           <a:lstStyle/>
           <a:p>
-            <a:fld id="{BE8087A8-B5D7-4357-AE59-6FD17618C1CA}" type="datetimeFigureOut">
+            <a:fld id="{73E72A7C-4DEC-4564-84EC-EE042061928E}" type="datetimeFigureOut">
               <a:rPr lang="zh-CN" altLang="en-US" smtClean="0"/>
               <a:t>2026/10/2</a:t>
             </a:fld>
@@ -1044,7 +1044,7 @@
           <a:bodyPr/>
           <a:lstStyle/>
           <a:p>
-            <a:fld id="{BBD35C1D-5E65-4137-BC2C-8F2F549B8297}" type="slidenum">
+            <a:fld id="{DD558A60-CB82-4CF8-8E8F-98547F9B331C}" type="slidenum">
               <a:rPr lang="zh-CN" altLang="en-US" smtClean="0"/>
               <a:t>‹#›</a:t>
             </a:fld>
@@ -1055,7 +1055,7 @@
     </p:spTree>
     <p:extLst>
       <p:ext uri="{BB962C8B-B14F-4D97-AF65-F5344CB8AC3E}">
-        <p14:creationId xmlns:p14="http://schemas.microsoft.com/office/powerpoint/2010/main" val="3035954344"/>
+        <p14:creationId xmlns:p14="http://schemas.microsoft.com/office/powerpoint/2010/main" val="3595035793"/>
       </p:ext>
     </p:extLst>
   </p:cSld>
@@ -1234,7 +1234,7 @@
           <a:bodyPr/>
           <a:lstStyle/>
           <a:p>
-            <a:fld id="{BE8087A8-B5D7-4357-AE59-6FD17618C1CA}" type="datetimeFigureOut">
+            <a:fld id="{73E72A7C-4DEC-4564-84EC-EE042061928E}" type="datetimeFigureOut">
               <a:rPr lang="zh-CN" altLang="en-US" smtClean="0"/>
               <a:t>2026/10/2</a:t>
             </a:fld>
@@ -1276,7 +1276,7 @@
           <a:bodyPr/>
           <a:lstStyle/>
           <a:p>
-            <a:fld id="{BBD35C1D-5E65-4137-BC2C-8F2F549B8297}" type="slidenum">
+            <a:fld id="{DD558A60-CB82-4CF8-8E8F-98547F9B331C}" type="slidenum">
               <a:rPr lang="zh-CN" altLang="en-US" smtClean="0"/>
               <a:t>‹#›</a:t>
             </a:fld>
@@ -1287,7 +1287,7 @@
     </p:spTree>
     <p:extLst>
       <p:ext uri="{BB962C8B-B14F-4D97-AF65-F5344CB8AC3E}">
-        <p14:creationId xmlns:p14="http://schemas.microsoft.com/office/powerpoint/2010/main" val="2293339222"/>
+        <p14:creationId xmlns:p14="http://schemas.microsoft.com/office/powerpoint/2010/main" val="1288431089"/>
       </p:ext>
     </p:extLst>
   </p:cSld>
@@ -1601,7 +1601,7 @@
           <a:bodyPr/>
           <a:lstStyle/>
           <a:p>
-            <a:fld id="{BE8087A8-B5D7-4357-AE59-6FD17618C1CA}" type="datetimeFigureOut">
+            <a:fld id="{73E72A7C-4DEC-4564-84EC-EE042061928E}" type="datetimeFigureOut">
               <a:rPr lang="zh-CN" altLang="en-US" smtClean="0"/>
               <a:t>2026/10/2</a:t>
             </a:fld>
@@ -1643,7 +1643,7 @@
           <a:bodyPr/>
           <a:lstStyle/>
           <a:p>
-            <a:fld id="{BBD35C1D-5E65-4137-BC2C-8F2F549B8297}" type="slidenum">
+            <a:fld id="{DD558A60-CB82-4CF8-8E8F-98547F9B331C}" type="slidenum">
               <a:rPr lang="zh-CN" altLang="en-US" smtClean="0"/>
               <a:t>‹#›</a:t>
             </a:fld>
@@ -1654,7 +1654,7 @@
     </p:spTree>
     <p:extLst>
       <p:ext uri="{BB962C8B-B14F-4D97-AF65-F5344CB8AC3E}">
-        <p14:creationId xmlns:p14="http://schemas.microsoft.com/office/powerpoint/2010/main" val="3892655281"/>
+        <p14:creationId xmlns:p14="http://schemas.microsoft.com/office/powerpoint/2010/main" val="2114433499"/>
       </p:ext>
     </p:extLst>
   </p:cSld>
@@ -1719,7 +1719,7 @@
           <a:bodyPr/>
           <a:lstStyle/>
           <a:p>
-            <a:fld id="{BE8087A8-B5D7-4357-AE59-6FD17618C1CA}" type="datetimeFigureOut">
+            <a:fld id="{73E72A7C-4DEC-4564-84EC-EE042061928E}" type="datetimeFigureOut">
               <a:rPr lang="zh-CN" altLang="en-US" smtClean="0"/>
               <a:t>2026/10/2</a:t>
             </a:fld>
@@ -1761,7 +1761,7 @@
           <a:bodyPr/>
           <a:lstStyle/>
           <a:p>
-            <a:fld id="{BBD35C1D-5E65-4137-BC2C-8F2F549B8297}" type="slidenum">
+            <a:fld id="{DD558A60-CB82-4CF8-8E8F-98547F9B331C}" type="slidenum">
               <a:rPr lang="zh-CN" altLang="en-US" smtClean="0"/>
               <a:t>‹#›</a:t>
             </a:fld>
@@ -1772,7 +1772,7 @@
     </p:spTree>
     <p:extLst>
       <p:ext uri="{BB962C8B-B14F-4D97-AF65-F5344CB8AC3E}">
-        <p14:creationId xmlns:p14="http://schemas.microsoft.com/office/powerpoint/2010/main" val="2927468478"/>
+        <p14:creationId xmlns:p14="http://schemas.microsoft.com/office/powerpoint/2010/main" val="1785885719"/>
       </p:ext>
     </p:extLst>
   </p:cSld>
@@ -1814,7 +1814,7 @@
           <a:bodyPr/>
           <a:lstStyle/>
           <a:p>
-            <a:fld id="{BE8087A8-B5D7-4357-AE59-6FD17618C1CA}" type="datetimeFigureOut">
+            <a:fld id="{73E72A7C-4DEC-4564-84EC-EE042061928E}" type="datetimeFigureOut">
               <a:rPr lang="zh-CN" altLang="en-US" smtClean="0"/>
               <a:t>2026/10/2</a:t>
             </a:fld>
@@ -1856,7 +1856,7 @@
           <a:bodyPr/>
           <a:lstStyle/>
           <a:p>
-            <a:fld id="{BBD35C1D-5E65-4137-BC2C-8F2F549B8297}" type="slidenum">
+            <a:fld id="{DD558A60-CB82-4CF8-8E8F-98547F9B331C}" type="slidenum">
               <a:rPr lang="zh-CN" altLang="en-US" smtClean="0"/>
               <a:t>‹#›</a:t>
             </a:fld>
@@ -1867,7 +1867,7 @@
     </p:spTree>
     <p:extLst>
       <p:ext uri="{BB962C8B-B14F-4D97-AF65-F5344CB8AC3E}">
-        <p14:creationId xmlns:p14="http://schemas.microsoft.com/office/powerpoint/2010/main" val="3577161591"/>
+        <p14:creationId xmlns:p14="http://schemas.microsoft.com/office/powerpoint/2010/main" val="2690419881"/>
       </p:ext>
     </p:extLst>
   </p:cSld>
@@ -2091,7 +2091,7 @@
           <a:bodyPr/>
           <a:lstStyle/>
           <a:p>
-            <a:fld id="{BE8087A8-B5D7-4357-AE59-6FD17618C1CA}" type="datetimeFigureOut">
+            <a:fld id="{73E72A7C-4DEC-4564-84EC-EE042061928E}" type="datetimeFigureOut">
               <a:rPr lang="zh-CN" altLang="en-US" smtClean="0"/>
               <a:t>2026/10/2</a:t>
             </a:fld>
@@ -2133,7 +2133,7 @@
           <a:bodyPr/>
           <a:lstStyle/>
           <a:p>
-            <a:fld id="{BBD35C1D-5E65-4137-BC2C-8F2F549B8297}" type="slidenum">
+            <a:fld id="{DD558A60-CB82-4CF8-8E8F-98547F9B331C}" type="slidenum">
               <a:rPr lang="zh-CN" altLang="en-US" smtClean="0"/>
               <a:t>‹#›</a:t>
             </a:fld>
@@ -2144,7 +2144,7 @@
     </p:spTree>
     <p:extLst>
       <p:ext uri="{BB962C8B-B14F-4D97-AF65-F5344CB8AC3E}">
-        <p14:creationId xmlns:p14="http://schemas.microsoft.com/office/powerpoint/2010/main" val="475292459"/>
+        <p14:creationId xmlns:p14="http://schemas.microsoft.com/office/powerpoint/2010/main" val="4266512136"/>
       </p:ext>
     </p:extLst>
   </p:cSld>
@@ -2344,7 +2344,7 @@
           <a:bodyPr/>
           <a:lstStyle/>
           <a:p>
-            <a:fld id="{BE8087A8-B5D7-4357-AE59-6FD17618C1CA}" type="datetimeFigureOut">
+            <a:fld id="{73E72A7C-4DEC-4564-84EC-EE042061928E}" type="datetimeFigureOut">
               <a:rPr lang="zh-CN" altLang="en-US" smtClean="0"/>
               <a:t>2026/10/2</a:t>
             </a:fld>
@@ -2386,7 +2386,7 @@
           <a:bodyPr/>
           <a:lstStyle/>
           <a:p>
-            <a:fld id="{BBD35C1D-5E65-4137-BC2C-8F2F549B8297}" type="slidenum">
+            <a:fld id="{DD558A60-CB82-4CF8-8E8F-98547F9B331C}" type="slidenum">
               <a:rPr lang="zh-CN" altLang="en-US" smtClean="0"/>
               <a:t>‹#›</a:t>
             </a:fld>
@@ -2397,7 +2397,7 @@
     </p:spTree>
     <p:extLst>
       <p:ext uri="{BB962C8B-B14F-4D97-AF65-F5344CB8AC3E}">
-        <p14:creationId xmlns:p14="http://schemas.microsoft.com/office/powerpoint/2010/main" val="3890189469"/>
+        <p14:creationId xmlns:p14="http://schemas.microsoft.com/office/powerpoint/2010/main" val="582893500"/>
       </p:ext>
     </p:extLst>
   </p:cSld>
@@ -2557,7 +2557,7 @@
             </a:lvl1pPr>
           </a:lstStyle>
           <a:p>
-            <a:fld id="{BE8087A8-B5D7-4357-AE59-6FD17618C1CA}" type="datetimeFigureOut">
+            <a:fld id="{73E72A7C-4DEC-4564-84EC-EE042061928E}" type="datetimeFigureOut">
               <a:rPr lang="zh-CN" altLang="en-US" smtClean="0"/>
               <a:t>2026/10/2</a:t>
             </a:fld>
@@ -2635,7 +2635,7 @@
             </a:lvl1pPr>
           </a:lstStyle>
           <a:p>
-            <a:fld id="{BBD35C1D-5E65-4137-BC2C-8F2F549B8297}" type="slidenum">
+            <a:fld id="{DD558A60-CB82-4CF8-8E8F-98547F9B331C}" type="slidenum">
               <a:rPr lang="zh-CN" altLang="en-US" smtClean="0"/>
               <a:t>‹#›</a:t>
             </a:fld>
@@ -2646,7 +2646,7 @@
     </p:spTree>
     <p:extLst>
       <p:ext uri="{BB962C8B-B14F-4D97-AF65-F5344CB8AC3E}">
-        <p14:creationId xmlns:p14="http://schemas.microsoft.com/office/powerpoint/2010/main" val="433720497"/>
+        <p14:creationId xmlns:p14="http://schemas.microsoft.com/office/powerpoint/2010/main" val="817139712"/>
       </p:ext>
     </p:extLst>
   </p:cSld>
@@ -3010,7 +3010,7 @@
     </p:spTree>
     <p:extLst>
       <p:ext uri="{BB962C8B-B14F-4D97-AF65-F5344CB8AC3E}">
-        <p14:creationId xmlns:p14="http://schemas.microsoft.com/office/powerpoint/2010/main" val="1156693805"/>
+        <p14:creationId xmlns:p14="http://schemas.microsoft.com/office/powerpoint/2010/main" val="169187421"/>
       </p:ext>
     </p:extLst>
   </p:cSld>

</xml_diff>

<commit_message>
check: accepted - local checks passed, loop closed
Co-authored-by: arena-agent <297053741+arena-agent@users.noreply.github.com>
</commit_message>
<xml_diff>
--- a/results/cell_ppt_edited/acceptance.pptx
+++ b/results/cell_ppt_edited/acceptance.pptx
@@ -236,7 +236,7 @@
           <a:bodyPr/>
           <a:lstStyle/>
           <a:p>
-            <a:fld id="{73E72A7C-4DEC-4564-84EC-EE042061928E}" type="datetimeFigureOut">
+            <a:fld id="{BE8087A8-B5D7-4357-AE59-6FD17618C1CA}" type="datetimeFigureOut">
               <a:rPr lang="zh-CN" altLang="en-US" smtClean="0"/>
               <a:t>2026/10/2</a:t>
             </a:fld>
@@ -278,7 +278,7 @@
           <a:bodyPr/>
           <a:lstStyle/>
           <a:p>
-            <a:fld id="{DD558A60-CB82-4CF8-8E8F-98547F9B331C}" type="slidenum">
+            <a:fld id="{BBD35C1D-5E65-4137-BC2C-8F2F549B8297}" type="slidenum">
               <a:rPr lang="zh-CN" altLang="en-US" smtClean="0"/>
               <a:t>‹#›</a:t>
             </a:fld>
@@ -289,7 +289,7 @@
     </p:spTree>
     <p:extLst>
       <p:ext uri="{BB962C8B-B14F-4D97-AF65-F5344CB8AC3E}">
-        <p14:creationId xmlns:p14="http://schemas.microsoft.com/office/powerpoint/2010/main" val="704060550"/>
+        <p14:creationId xmlns:p14="http://schemas.microsoft.com/office/powerpoint/2010/main" val="2630955929"/>
       </p:ext>
     </p:extLst>
   </p:cSld>
@@ -406,7 +406,7 @@
           <a:bodyPr/>
           <a:lstStyle/>
           <a:p>
-            <a:fld id="{73E72A7C-4DEC-4564-84EC-EE042061928E}" type="datetimeFigureOut">
+            <a:fld id="{BE8087A8-B5D7-4357-AE59-6FD17618C1CA}" type="datetimeFigureOut">
               <a:rPr lang="zh-CN" altLang="en-US" smtClean="0"/>
               <a:t>2026/10/2</a:t>
             </a:fld>
@@ -448,7 +448,7 @@
           <a:bodyPr/>
           <a:lstStyle/>
           <a:p>
-            <a:fld id="{DD558A60-CB82-4CF8-8E8F-98547F9B331C}" type="slidenum">
+            <a:fld id="{BBD35C1D-5E65-4137-BC2C-8F2F549B8297}" type="slidenum">
               <a:rPr lang="zh-CN" altLang="en-US" smtClean="0"/>
               <a:t>‹#›</a:t>
             </a:fld>
@@ -459,7 +459,7 @@
     </p:spTree>
     <p:extLst>
       <p:ext uri="{BB962C8B-B14F-4D97-AF65-F5344CB8AC3E}">
-        <p14:creationId xmlns:p14="http://schemas.microsoft.com/office/powerpoint/2010/main" val="1461297895"/>
+        <p14:creationId xmlns:p14="http://schemas.microsoft.com/office/powerpoint/2010/main" val="434466824"/>
       </p:ext>
     </p:extLst>
   </p:cSld>
@@ -586,7 +586,7 @@
           <a:bodyPr/>
           <a:lstStyle/>
           <a:p>
-            <a:fld id="{73E72A7C-4DEC-4564-84EC-EE042061928E}" type="datetimeFigureOut">
+            <a:fld id="{BE8087A8-B5D7-4357-AE59-6FD17618C1CA}" type="datetimeFigureOut">
               <a:rPr lang="zh-CN" altLang="en-US" smtClean="0"/>
               <a:t>2026/10/2</a:t>
             </a:fld>
@@ -628,7 +628,7 @@
           <a:bodyPr/>
           <a:lstStyle/>
           <a:p>
-            <a:fld id="{DD558A60-CB82-4CF8-8E8F-98547F9B331C}" type="slidenum">
+            <a:fld id="{BBD35C1D-5E65-4137-BC2C-8F2F549B8297}" type="slidenum">
               <a:rPr lang="zh-CN" altLang="en-US" smtClean="0"/>
               <a:t>‹#›</a:t>
             </a:fld>
@@ -639,7 +639,7 @@
     </p:spTree>
     <p:extLst>
       <p:ext uri="{BB962C8B-B14F-4D97-AF65-F5344CB8AC3E}">
-        <p14:creationId xmlns:p14="http://schemas.microsoft.com/office/powerpoint/2010/main" val="1980127114"/>
+        <p14:creationId xmlns:p14="http://schemas.microsoft.com/office/powerpoint/2010/main" val="1042765240"/>
       </p:ext>
     </p:extLst>
   </p:cSld>
@@ -756,7 +756,7 @@
           <a:bodyPr/>
           <a:lstStyle/>
           <a:p>
-            <a:fld id="{73E72A7C-4DEC-4564-84EC-EE042061928E}" type="datetimeFigureOut">
+            <a:fld id="{BE8087A8-B5D7-4357-AE59-6FD17618C1CA}" type="datetimeFigureOut">
               <a:rPr lang="zh-CN" altLang="en-US" smtClean="0"/>
               <a:t>2026/10/2</a:t>
             </a:fld>
@@ -798,7 +798,7 @@
           <a:bodyPr/>
           <a:lstStyle/>
           <a:p>
-            <a:fld id="{DD558A60-CB82-4CF8-8E8F-98547F9B331C}" type="slidenum">
+            <a:fld id="{BBD35C1D-5E65-4137-BC2C-8F2F549B8297}" type="slidenum">
               <a:rPr lang="zh-CN" altLang="en-US" smtClean="0"/>
               <a:t>‹#›</a:t>
             </a:fld>
@@ -809,7 +809,7 @@
     </p:spTree>
     <p:extLst>
       <p:ext uri="{BB962C8B-B14F-4D97-AF65-F5344CB8AC3E}">
-        <p14:creationId xmlns:p14="http://schemas.microsoft.com/office/powerpoint/2010/main" val="1611081952"/>
+        <p14:creationId xmlns:p14="http://schemas.microsoft.com/office/powerpoint/2010/main" val="1346274400"/>
       </p:ext>
     </p:extLst>
   </p:cSld>
@@ -1002,7 +1002,7 @@
           <a:bodyPr/>
           <a:lstStyle/>
           <a:p>
-            <a:fld id="{73E72A7C-4DEC-4564-84EC-EE042061928E}" type="datetimeFigureOut">
+            <a:fld id="{BE8087A8-B5D7-4357-AE59-6FD17618C1CA}" type="datetimeFigureOut">
               <a:rPr lang="zh-CN" altLang="en-US" smtClean="0"/>
               <a:t>2026/10/2</a:t>
             </a:fld>
@@ -1044,7 +1044,7 @@
           <a:bodyPr/>
           <a:lstStyle/>
           <a:p>
-            <a:fld id="{DD558A60-CB82-4CF8-8E8F-98547F9B331C}" type="slidenum">
+            <a:fld id="{BBD35C1D-5E65-4137-BC2C-8F2F549B8297}" type="slidenum">
               <a:rPr lang="zh-CN" altLang="en-US" smtClean="0"/>
               <a:t>‹#›</a:t>
             </a:fld>
@@ -1055,7 +1055,7 @@
     </p:spTree>
     <p:extLst>
       <p:ext uri="{BB962C8B-B14F-4D97-AF65-F5344CB8AC3E}">
-        <p14:creationId xmlns:p14="http://schemas.microsoft.com/office/powerpoint/2010/main" val="3595035793"/>
+        <p14:creationId xmlns:p14="http://schemas.microsoft.com/office/powerpoint/2010/main" val="3035954344"/>
       </p:ext>
     </p:extLst>
   </p:cSld>
@@ -1234,7 +1234,7 @@
           <a:bodyPr/>
           <a:lstStyle/>
           <a:p>
-            <a:fld id="{73E72A7C-4DEC-4564-84EC-EE042061928E}" type="datetimeFigureOut">
+            <a:fld id="{BE8087A8-B5D7-4357-AE59-6FD17618C1CA}" type="datetimeFigureOut">
               <a:rPr lang="zh-CN" altLang="en-US" smtClean="0"/>
               <a:t>2026/10/2</a:t>
             </a:fld>
@@ -1276,7 +1276,7 @@
           <a:bodyPr/>
           <a:lstStyle/>
           <a:p>
-            <a:fld id="{DD558A60-CB82-4CF8-8E8F-98547F9B331C}" type="slidenum">
+            <a:fld id="{BBD35C1D-5E65-4137-BC2C-8F2F549B8297}" type="slidenum">
               <a:rPr lang="zh-CN" altLang="en-US" smtClean="0"/>
               <a:t>‹#›</a:t>
             </a:fld>
@@ -1287,7 +1287,7 @@
     </p:spTree>
     <p:extLst>
       <p:ext uri="{BB962C8B-B14F-4D97-AF65-F5344CB8AC3E}">
-        <p14:creationId xmlns:p14="http://schemas.microsoft.com/office/powerpoint/2010/main" val="1288431089"/>
+        <p14:creationId xmlns:p14="http://schemas.microsoft.com/office/powerpoint/2010/main" val="2293339222"/>
       </p:ext>
     </p:extLst>
   </p:cSld>
@@ -1601,7 +1601,7 @@
           <a:bodyPr/>
           <a:lstStyle/>
           <a:p>
-            <a:fld id="{73E72A7C-4DEC-4564-84EC-EE042061928E}" type="datetimeFigureOut">
+            <a:fld id="{BE8087A8-B5D7-4357-AE59-6FD17618C1CA}" type="datetimeFigureOut">
               <a:rPr lang="zh-CN" altLang="en-US" smtClean="0"/>
               <a:t>2026/10/2</a:t>
             </a:fld>
@@ -1643,7 +1643,7 @@
           <a:bodyPr/>
           <a:lstStyle/>
           <a:p>
-            <a:fld id="{DD558A60-CB82-4CF8-8E8F-98547F9B331C}" type="slidenum">
+            <a:fld id="{BBD35C1D-5E65-4137-BC2C-8F2F549B8297}" type="slidenum">
               <a:rPr lang="zh-CN" altLang="en-US" smtClean="0"/>
               <a:t>‹#›</a:t>
             </a:fld>
@@ -1654,7 +1654,7 @@
     </p:spTree>
     <p:extLst>
       <p:ext uri="{BB962C8B-B14F-4D97-AF65-F5344CB8AC3E}">
-        <p14:creationId xmlns:p14="http://schemas.microsoft.com/office/powerpoint/2010/main" val="2114433499"/>
+        <p14:creationId xmlns:p14="http://schemas.microsoft.com/office/powerpoint/2010/main" val="3892655281"/>
       </p:ext>
     </p:extLst>
   </p:cSld>
@@ -1719,7 +1719,7 @@
           <a:bodyPr/>
           <a:lstStyle/>
           <a:p>
-            <a:fld id="{73E72A7C-4DEC-4564-84EC-EE042061928E}" type="datetimeFigureOut">
+            <a:fld id="{BE8087A8-B5D7-4357-AE59-6FD17618C1CA}" type="datetimeFigureOut">
               <a:rPr lang="zh-CN" altLang="en-US" smtClean="0"/>
               <a:t>2026/10/2</a:t>
             </a:fld>
@@ -1761,7 +1761,7 @@
           <a:bodyPr/>
           <a:lstStyle/>
           <a:p>
-            <a:fld id="{DD558A60-CB82-4CF8-8E8F-98547F9B331C}" type="slidenum">
+            <a:fld id="{BBD35C1D-5E65-4137-BC2C-8F2F549B8297}" type="slidenum">
               <a:rPr lang="zh-CN" altLang="en-US" smtClean="0"/>
               <a:t>‹#›</a:t>
             </a:fld>
@@ -1772,7 +1772,7 @@
     </p:spTree>
     <p:extLst>
       <p:ext uri="{BB962C8B-B14F-4D97-AF65-F5344CB8AC3E}">
-        <p14:creationId xmlns:p14="http://schemas.microsoft.com/office/powerpoint/2010/main" val="1785885719"/>
+        <p14:creationId xmlns:p14="http://schemas.microsoft.com/office/powerpoint/2010/main" val="2927468478"/>
       </p:ext>
     </p:extLst>
   </p:cSld>
@@ -1814,7 +1814,7 @@
           <a:bodyPr/>
           <a:lstStyle/>
           <a:p>
-            <a:fld id="{73E72A7C-4DEC-4564-84EC-EE042061928E}" type="datetimeFigureOut">
+            <a:fld id="{BE8087A8-B5D7-4357-AE59-6FD17618C1CA}" type="datetimeFigureOut">
               <a:rPr lang="zh-CN" altLang="en-US" smtClean="0"/>
               <a:t>2026/10/2</a:t>
             </a:fld>
@@ -1856,7 +1856,7 @@
           <a:bodyPr/>
           <a:lstStyle/>
           <a:p>
-            <a:fld id="{DD558A60-CB82-4CF8-8E8F-98547F9B331C}" type="slidenum">
+            <a:fld id="{BBD35C1D-5E65-4137-BC2C-8F2F549B8297}" type="slidenum">
               <a:rPr lang="zh-CN" altLang="en-US" smtClean="0"/>
               <a:t>‹#›</a:t>
             </a:fld>
@@ -1867,7 +1867,7 @@
     </p:spTree>
     <p:extLst>
       <p:ext uri="{BB962C8B-B14F-4D97-AF65-F5344CB8AC3E}">
-        <p14:creationId xmlns:p14="http://schemas.microsoft.com/office/powerpoint/2010/main" val="2690419881"/>
+        <p14:creationId xmlns:p14="http://schemas.microsoft.com/office/powerpoint/2010/main" val="3577161591"/>
       </p:ext>
     </p:extLst>
   </p:cSld>
@@ -2091,7 +2091,7 @@
           <a:bodyPr/>
           <a:lstStyle/>
           <a:p>
-            <a:fld id="{73E72A7C-4DEC-4564-84EC-EE042061928E}" type="datetimeFigureOut">
+            <a:fld id="{BE8087A8-B5D7-4357-AE59-6FD17618C1CA}" type="datetimeFigureOut">
               <a:rPr lang="zh-CN" altLang="en-US" smtClean="0"/>
               <a:t>2026/10/2</a:t>
             </a:fld>
@@ -2133,7 +2133,7 @@
           <a:bodyPr/>
           <a:lstStyle/>
           <a:p>
-            <a:fld id="{DD558A60-CB82-4CF8-8E8F-98547F9B331C}" type="slidenum">
+            <a:fld id="{BBD35C1D-5E65-4137-BC2C-8F2F549B8297}" type="slidenum">
               <a:rPr lang="zh-CN" altLang="en-US" smtClean="0"/>
               <a:t>‹#›</a:t>
             </a:fld>
@@ -2144,7 +2144,7 @@
     </p:spTree>
     <p:extLst>
       <p:ext uri="{BB962C8B-B14F-4D97-AF65-F5344CB8AC3E}">
-        <p14:creationId xmlns:p14="http://schemas.microsoft.com/office/powerpoint/2010/main" val="4266512136"/>
+        <p14:creationId xmlns:p14="http://schemas.microsoft.com/office/powerpoint/2010/main" val="475292459"/>
       </p:ext>
     </p:extLst>
   </p:cSld>
@@ -2344,7 +2344,7 @@
           <a:bodyPr/>
           <a:lstStyle/>
           <a:p>
-            <a:fld id="{73E72A7C-4DEC-4564-84EC-EE042061928E}" type="datetimeFigureOut">
+            <a:fld id="{BE8087A8-B5D7-4357-AE59-6FD17618C1CA}" type="datetimeFigureOut">
               <a:rPr lang="zh-CN" altLang="en-US" smtClean="0"/>
               <a:t>2026/10/2</a:t>
             </a:fld>
@@ -2386,7 +2386,7 @@
           <a:bodyPr/>
           <a:lstStyle/>
           <a:p>
-            <a:fld id="{DD558A60-CB82-4CF8-8E8F-98547F9B331C}" type="slidenum">
+            <a:fld id="{BBD35C1D-5E65-4137-BC2C-8F2F549B8297}" type="slidenum">
               <a:rPr lang="zh-CN" altLang="en-US" smtClean="0"/>
               <a:t>‹#›</a:t>
             </a:fld>
@@ -2397,7 +2397,7 @@
     </p:spTree>
     <p:extLst>
       <p:ext uri="{BB962C8B-B14F-4D97-AF65-F5344CB8AC3E}">
-        <p14:creationId xmlns:p14="http://schemas.microsoft.com/office/powerpoint/2010/main" val="582893500"/>
+        <p14:creationId xmlns:p14="http://schemas.microsoft.com/office/powerpoint/2010/main" val="3890189469"/>
       </p:ext>
     </p:extLst>
   </p:cSld>
@@ -2557,7 +2557,7 @@
             </a:lvl1pPr>
           </a:lstStyle>
           <a:p>
-            <a:fld id="{73E72A7C-4DEC-4564-84EC-EE042061928E}" type="datetimeFigureOut">
+            <a:fld id="{BE8087A8-B5D7-4357-AE59-6FD17618C1CA}" type="datetimeFigureOut">
               <a:rPr lang="zh-CN" altLang="en-US" smtClean="0"/>
               <a:t>2026/10/2</a:t>
             </a:fld>
@@ -2635,7 +2635,7 @@
             </a:lvl1pPr>
           </a:lstStyle>
           <a:p>
-            <a:fld id="{DD558A60-CB82-4CF8-8E8F-98547F9B331C}" type="slidenum">
+            <a:fld id="{BBD35C1D-5E65-4137-BC2C-8F2F549B8297}" type="slidenum">
               <a:rPr lang="zh-CN" altLang="en-US" smtClean="0"/>
               <a:t>‹#›</a:t>
             </a:fld>
@@ -2646,7 +2646,7 @@
     </p:spTree>
     <p:extLst>
       <p:ext uri="{BB962C8B-B14F-4D97-AF65-F5344CB8AC3E}">
-        <p14:creationId xmlns:p14="http://schemas.microsoft.com/office/powerpoint/2010/main" val="817139712"/>
+        <p14:creationId xmlns:p14="http://schemas.microsoft.com/office/powerpoint/2010/main" val="433720497"/>
       </p:ext>
     </p:extLst>
   </p:cSld>
@@ -3010,7 +3010,7 @@
     </p:spTree>
     <p:extLst>
       <p:ext uri="{BB962C8B-B14F-4D97-AF65-F5344CB8AC3E}">
-        <p14:creationId xmlns:p14="http://schemas.microsoft.com/office/powerpoint/2010/main" val="169187421"/>
+        <p14:creationId xmlns:p14="http://schemas.microsoft.com/office/powerpoint/2010/main" val="1156693805"/>
       </p:ext>
     </p:extLst>
   </p:cSld>

</xml_diff>

<commit_message>
check: round 170 passed
</commit_message>
<xml_diff>
--- a/results/cell_ppt_edited/acceptance.pptx
+++ b/results/cell_ppt_edited/acceptance.pptx
@@ -236,7 +236,7 @@
           <a:bodyPr/>
           <a:lstStyle/>
           <a:p>
-            <a:fld id="{BE8087A8-B5D7-4357-AE59-6FD17618C1CA}" type="datetimeFigureOut">
+            <a:fld id="{2CBFE1A6-1EDE-43C3-8708-5C69F48BFA76}" type="datetimeFigureOut">
               <a:rPr lang="zh-CN" altLang="en-US" smtClean="0"/>
               <a:t>2026/10/2</a:t>
             </a:fld>
@@ -278,7 +278,7 @@
           <a:bodyPr/>
           <a:lstStyle/>
           <a:p>
-            <a:fld id="{BBD35C1D-5E65-4137-BC2C-8F2F549B8297}" type="slidenum">
+            <a:fld id="{4843113D-A424-4920-AA1B-3C01F4E50B15}" type="slidenum">
               <a:rPr lang="zh-CN" altLang="en-US" smtClean="0"/>
               <a:t>‹#›</a:t>
             </a:fld>
@@ -289,7 +289,7 @@
     </p:spTree>
     <p:extLst>
       <p:ext uri="{BB962C8B-B14F-4D97-AF65-F5344CB8AC3E}">
-        <p14:creationId xmlns:p14="http://schemas.microsoft.com/office/powerpoint/2010/main" val="2630955929"/>
+        <p14:creationId xmlns:p14="http://schemas.microsoft.com/office/powerpoint/2010/main" val="4167644383"/>
       </p:ext>
     </p:extLst>
   </p:cSld>
@@ -406,7 +406,7 @@
           <a:bodyPr/>
           <a:lstStyle/>
           <a:p>
-            <a:fld id="{BE8087A8-B5D7-4357-AE59-6FD17618C1CA}" type="datetimeFigureOut">
+            <a:fld id="{2CBFE1A6-1EDE-43C3-8708-5C69F48BFA76}" type="datetimeFigureOut">
               <a:rPr lang="zh-CN" altLang="en-US" smtClean="0"/>
               <a:t>2026/10/2</a:t>
             </a:fld>
@@ -448,7 +448,7 @@
           <a:bodyPr/>
           <a:lstStyle/>
           <a:p>
-            <a:fld id="{BBD35C1D-5E65-4137-BC2C-8F2F549B8297}" type="slidenum">
+            <a:fld id="{4843113D-A424-4920-AA1B-3C01F4E50B15}" type="slidenum">
               <a:rPr lang="zh-CN" altLang="en-US" smtClean="0"/>
               <a:t>‹#›</a:t>
             </a:fld>
@@ -459,7 +459,7 @@
     </p:spTree>
     <p:extLst>
       <p:ext uri="{BB962C8B-B14F-4D97-AF65-F5344CB8AC3E}">
-        <p14:creationId xmlns:p14="http://schemas.microsoft.com/office/powerpoint/2010/main" val="434466824"/>
+        <p14:creationId xmlns:p14="http://schemas.microsoft.com/office/powerpoint/2010/main" val="4202129759"/>
       </p:ext>
     </p:extLst>
   </p:cSld>
@@ -586,7 +586,7 @@
           <a:bodyPr/>
           <a:lstStyle/>
           <a:p>
-            <a:fld id="{BE8087A8-B5D7-4357-AE59-6FD17618C1CA}" type="datetimeFigureOut">
+            <a:fld id="{2CBFE1A6-1EDE-43C3-8708-5C69F48BFA76}" type="datetimeFigureOut">
               <a:rPr lang="zh-CN" altLang="en-US" smtClean="0"/>
               <a:t>2026/10/2</a:t>
             </a:fld>
@@ -628,7 +628,7 @@
           <a:bodyPr/>
           <a:lstStyle/>
           <a:p>
-            <a:fld id="{BBD35C1D-5E65-4137-BC2C-8F2F549B8297}" type="slidenum">
+            <a:fld id="{4843113D-A424-4920-AA1B-3C01F4E50B15}" type="slidenum">
               <a:rPr lang="zh-CN" altLang="en-US" smtClean="0"/>
               <a:t>‹#›</a:t>
             </a:fld>
@@ -639,7 +639,7 @@
     </p:spTree>
     <p:extLst>
       <p:ext uri="{BB962C8B-B14F-4D97-AF65-F5344CB8AC3E}">
-        <p14:creationId xmlns:p14="http://schemas.microsoft.com/office/powerpoint/2010/main" val="1042765240"/>
+        <p14:creationId xmlns:p14="http://schemas.microsoft.com/office/powerpoint/2010/main" val="303371109"/>
       </p:ext>
     </p:extLst>
   </p:cSld>
@@ -756,7 +756,7 @@
           <a:bodyPr/>
           <a:lstStyle/>
           <a:p>
-            <a:fld id="{BE8087A8-B5D7-4357-AE59-6FD17618C1CA}" type="datetimeFigureOut">
+            <a:fld id="{2CBFE1A6-1EDE-43C3-8708-5C69F48BFA76}" type="datetimeFigureOut">
               <a:rPr lang="zh-CN" altLang="en-US" smtClean="0"/>
               <a:t>2026/10/2</a:t>
             </a:fld>
@@ -798,7 +798,7 @@
           <a:bodyPr/>
           <a:lstStyle/>
           <a:p>
-            <a:fld id="{BBD35C1D-5E65-4137-BC2C-8F2F549B8297}" type="slidenum">
+            <a:fld id="{4843113D-A424-4920-AA1B-3C01F4E50B15}" type="slidenum">
               <a:rPr lang="zh-CN" altLang="en-US" smtClean="0"/>
               <a:t>‹#›</a:t>
             </a:fld>
@@ -809,7 +809,7 @@
     </p:spTree>
     <p:extLst>
       <p:ext uri="{BB962C8B-B14F-4D97-AF65-F5344CB8AC3E}">
-        <p14:creationId xmlns:p14="http://schemas.microsoft.com/office/powerpoint/2010/main" val="1346274400"/>
+        <p14:creationId xmlns:p14="http://schemas.microsoft.com/office/powerpoint/2010/main" val="3212955063"/>
       </p:ext>
     </p:extLst>
   </p:cSld>
@@ -1002,7 +1002,7 @@
           <a:bodyPr/>
           <a:lstStyle/>
           <a:p>
-            <a:fld id="{BE8087A8-B5D7-4357-AE59-6FD17618C1CA}" type="datetimeFigureOut">
+            <a:fld id="{2CBFE1A6-1EDE-43C3-8708-5C69F48BFA76}" type="datetimeFigureOut">
               <a:rPr lang="zh-CN" altLang="en-US" smtClean="0"/>
               <a:t>2026/10/2</a:t>
             </a:fld>
@@ -1044,7 +1044,7 @@
           <a:bodyPr/>
           <a:lstStyle/>
           <a:p>
-            <a:fld id="{BBD35C1D-5E65-4137-BC2C-8F2F549B8297}" type="slidenum">
+            <a:fld id="{4843113D-A424-4920-AA1B-3C01F4E50B15}" type="slidenum">
               <a:rPr lang="zh-CN" altLang="en-US" smtClean="0"/>
               <a:t>‹#›</a:t>
             </a:fld>
@@ -1055,7 +1055,7 @@
     </p:spTree>
     <p:extLst>
       <p:ext uri="{BB962C8B-B14F-4D97-AF65-F5344CB8AC3E}">
-        <p14:creationId xmlns:p14="http://schemas.microsoft.com/office/powerpoint/2010/main" val="3035954344"/>
+        <p14:creationId xmlns:p14="http://schemas.microsoft.com/office/powerpoint/2010/main" val="2060422334"/>
       </p:ext>
     </p:extLst>
   </p:cSld>
@@ -1234,7 +1234,7 @@
           <a:bodyPr/>
           <a:lstStyle/>
           <a:p>
-            <a:fld id="{BE8087A8-B5D7-4357-AE59-6FD17618C1CA}" type="datetimeFigureOut">
+            <a:fld id="{2CBFE1A6-1EDE-43C3-8708-5C69F48BFA76}" type="datetimeFigureOut">
               <a:rPr lang="zh-CN" altLang="en-US" smtClean="0"/>
               <a:t>2026/10/2</a:t>
             </a:fld>
@@ -1276,7 +1276,7 @@
           <a:bodyPr/>
           <a:lstStyle/>
           <a:p>
-            <a:fld id="{BBD35C1D-5E65-4137-BC2C-8F2F549B8297}" type="slidenum">
+            <a:fld id="{4843113D-A424-4920-AA1B-3C01F4E50B15}" type="slidenum">
               <a:rPr lang="zh-CN" altLang="en-US" smtClean="0"/>
               <a:t>‹#›</a:t>
             </a:fld>
@@ -1287,7 +1287,7 @@
     </p:spTree>
     <p:extLst>
       <p:ext uri="{BB962C8B-B14F-4D97-AF65-F5344CB8AC3E}">
-        <p14:creationId xmlns:p14="http://schemas.microsoft.com/office/powerpoint/2010/main" val="2293339222"/>
+        <p14:creationId xmlns:p14="http://schemas.microsoft.com/office/powerpoint/2010/main" val="1570279002"/>
       </p:ext>
     </p:extLst>
   </p:cSld>
@@ -1601,7 +1601,7 @@
           <a:bodyPr/>
           <a:lstStyle/>
           <a:p>
-            <a:fld id="{BE8087A8-B5D7-4357-AE59-6FD17618C1CA}" type="datetimeFigureOut">
+            <a:fld id="{2CBFE1A6-1EDE-43C3-8708-5C69F48BFA76}" type="datetimeFigureOut">
               <a:rPr lang="zh-CN" altLang="en-US" smtClean="0"/>
               <a:t>2026/10/2</a:t>
             </a:fld>
@@ -1643,7 +1643,7 @@
           <a:bodyPr/>
           <a:lstStyle/>
           <a:p>
-            <a:fld id="{BBD35C1D-5E65-4137-BC2C-8F2F549B8297}" type="slidenum">
+            <a:fld id="{4843113D-A424-4920-AA1B-3C01F4E50B15}" type="slidenum">
               <a:rPr lang="zh-CN" altLang="en-US" smtClean="0"/>
               <a:t>‹#›</a:t>
             </a:fld>
@@ -1654,7 +1654,7 @@
     </p:spTree>
     <p:extLst>
       <p:ext uri="{BB962C8B-B14F-4D97-AF65-F5344CB8AC3E}">
-        <p14:creationId xmlns:p14="http://schemas.microsoft.com/office/powerpoint/2010/main" val="3892655281"/>
+        <p14:creationId xmlns:p14="http://schemas.microsoft.com/office/powerpoint/2010/main" val="3855045553"/>
       </p:ext>
     </p:extLst>
   </p:cSld>
@@ -1719,7 +1719,7 @@
           <a:bodyPr/>
           <a:lstStyle/>
           <a:p>
-            <a:fld id="{BE8087A8-B5D7-4357-AE59-6FD17618C1CA}" type="datetimeFigureOut">
+            <a:fld id="{2CBFE1A6-1EDE-43C3-8708-5C69F48BFA76}" type="datetimeFigureOut">
               <a:rPr lang="zh-CN" altLang="en-US" smtClean="0"/>
               <a:t>2026/10/2</a:t>
             </a:fld>
@@ -1761,7 +1761,7 @@
           <a:bodyPr/>
           <a:lstStyle/>
           <a:p>
-            <a:fld id="{BBD35C1D-5E65-4137-BC2C-8F2F549B8297}" type="slidenum">
+            <a:fld id="{4843113D-A424-4920-AA1B-3C01F4E50B15}" type="slidenum">
               <a:rPr lang="zh-CN" altLang="en-US" smtClean="0"/>
               <a:t>‹#›</a:t>
             </a:fld>
@@ -1772,7 +1772,7 @@
     </p:spTree>
     <p:extLst>
       <p:ext uri="{BB962C8B-B14F-4D97-AF65-F5344CB8AC3E}">
-        <p14:creationId xmlns:p14="http://schemas.microsoft.com/office/powerpoint/2010/main" val="2927468478"/>
+        <p14:creationId xmlns:p14="http://schemas.microsoft.com/office/powerpoint/2010/main" val="563601100"/>
       </p:ext>
     </p:extLst>
   </p:cSld>
@@ -1814,7 +1814,7 @@
           <a:bodyPr/>
           <a:lstStyle/>
           <a:p>
-            <a:fld id="{BE8087A8-B5D7-4357-AE59-6FD17618C1CA}" type="datetimeFigureOut">
+            <a:fld id="{2CBFE1A6-1EDE-43C3-8708-5C69F48BFA76}" type="datetimeFigureOut">
               <a:rPr lang="zh-CN" altLang="en-US" smtClean="0"/>
               <a:t>2026/10/2</a:t>
             </a:fld>
@@ -1856,7 +1856,7 @@
           <a:bodyPr/>
           <a:lstStyle/>
           <a:p>
-            <a:fld id="{BBD35C1D-5E65-4137-BC2C-8F2F549B8297}" type="slidenum">
+            <a:fld id="{4843113D-A424-4920-AA1B-3C01F4E50B15}" type="slidenum">
               <a:rPr lang="zh-CN" altLang="en-US" smtClean="0"/>
               <a:t>‹#›</a:t>
             </a:fld>
@@ -1867,7 +1867,7 @@
     </p:spTree>
     <p:extLst>
       <p:ext uri="{BB962C8B-B14F-4D97-AF65-F5344CB8AC3E}">
-        <p14:creationId xmlns:p14="http://schemas.microsoft.com/office/powerpoint/2010/main" val="3577161591"/>
+        <p14:creationId xmlns:p14="http://schemas.microsoft.com/office/powerpoint/2010/main" val="2733693089"/>
       </p:ext>
     </p:extLst>
   </p:cSld>
@@ -2091,7 +2091,7 @@
           <a:bodyPr/>
           <a:lstStyle/>
           <a:p>
-            <a:fld id="{BE8087A8-B5D7-4357-AE59-6FD17618C1CA}" type="datetimeFigureOut">
+            <a:fld id="{2CBFE1A6-1EDE-43C3-8708-5C69F48BFA76}" type="datetimeFigureOut">
               <a:rPr lang="zh-CN" altLang="en-US" smtClean="0"/>
               <a:t>2026/10/2</a:t>
             </a:fld>
@@ -2133,7 +2133,7 @@
           <a:bodyPr/>
           <a:lstStyle/>
           <a:p>
-            <a:fld id="{BBD35C1D-5E65-4137-BC2C-8F2F549B8297}" type="slidenum">
+            <a:fld id="{4843113D-A424-4920-AA1B-3C01F4E50B15}" type="slidenum">
               <a:rPr lang="zh-CN" altLang="en-US" smtClean="0"/>
               <a:t>‹#›</a:t>
             </a:fld>
@@ -2144,7 +2144,7 @@
     </p:spTree>
     <p:extLst>
       <p:ext uri="{BB962C8B-B14F-4D97-AF65-F5344CB8AC3E}">
-        <p14:creationId xmlns:p14="http://schemas.microsoft.com/office/powerpoint/2010/main" val="475292459"/>
+        <p14:creationId xmlns:p14="http://schemas.microsoft.com/office/powerpoint/2010/main" val="466091560"/>
       </p:ext>
     </p:extLst>
   </p:cSld>
@@ -2344,7 +2344,7 @@
           <a:bodyPr/>
           <a:lstStyle/>
           <a:p>
-            <a:fld id="{BE8087A8-B5D7-4357-AE59-6FD17618C1CA}" type="datetimeFigureOut">
+            <a:fld id="{2CBFE1A6-1EDE-43C3-8708-5C69F48BFA76}" type="datetimeFigureOut">
               <a:rPr lang="zh-CN" altLang="en-US" smtClean="0"/>
               <a:t>2026/10/2</a:t>
             </a:fld>
@@ -2386,7 +2386,7 @@
           <a:bodyPr/>
           <a:lstStyle/>
           <a:p>
-            <a:fld id="{BBD35C1D-5E65-4137-BC2C-8F2F549B8297}" type="slidenum">
+            <a:fld id="{4843113D-A424-4920-AA1B-3C01F4E50B15}" type="slidenum">
               <a:rPr lang="zh-CN" altLang="en-US" smtClean="0"/>
               <a:t>‹#›</a:t>
             </a:fld>
@@ -2397,7 +2397,7 @@
     </p:spTree>
     <p:extLst>
       <p:ext uri="{BB962C8B-B14F-4D97-AF65-F5344CB8AC3E}">
-        <p14:creationId xmlns:p14="http://schemas.microsoft.com/office/powerpoint/2010/main" val="3890189469"/>
+        <p14:creationId xmlns:p14="http://schemas.microsoft.com/office/powerpoint/2010/main" val="412146200"/>
       </p:ext>
     </p:extLst>
   </p:cSld>
@@ -2557,7 +2557,7 @@
             </a:lvl1pPr>
           </a:lstStyle>
           <a:p>
-            <a:fld id="{BE8087A8-B5D7-4357-AE59-6FD17618C1CA}" type="datetimeFigureOut">
+            <a:fld id="{2CBFE1A6-1EDE-43C3-8708-5C69F48BFA76}" type="datetimeFigureOut">
               <a:rPr lang="zh-CN" altLang="en-US" smtClean="0"/>
               <a:t>2026/10/2</a:t>
             </a:fld>
@@ -2635,7 +2635,7 @@
             </a:lvl1pPr>
           </a:lstStyle>
           <a:p>
-            <a:fld id="{BBD35C1D-5E65-4137-BC2C-8F2F549B8297}" type="slidenum">
+            <a:fld id="{4843113D-A424-4920-AA1B-3C01F4E50B15}" type="slidenum">
               <a:rPr lang="zh-CN" altLang="en-US" smtClean="0"/>
               <a:t>‹#›</a:t>
             </a:fld>
@@ -2646,7 +2646,7 @@
     </p:spTree>
     <p:extLst>
       <p:ext uri="{BB962C8B-B14F-4D97-AF65-F5344CB8AC3E}">
-        <p14:creationId xmlns:p14="http://schemas.microsoft.com/office/powerpoint/2010/main" val="433720497"/>
+        <p14:creationId xmlns:p14="http://schemas.microsoft.com/office/powerpoint/2010/main" val="1437470306"/>
       </p:ext>
     </p:extLst>
   </p:cSld>
@@ -3010,7 +3010,7 @@
     </p:spTree>
     <p:extLst>
       <p:ext uri="{BB962C8B-B14F-4D97-AF65-F5344CB8AC3E}">
-        <p14:creationId xmlns:p14="http://schemas.microsoft.com/office/powerpoint/2010/main" val="1156693805"/>
+        <p14:creationId xmlns:p14="http://schemas.microsoft.com/office/powerpoint/2010/main" val="4065223203"/>
       </p:ext>
     </p:extLst>
   </p:cSld>

</xml_diff>

<commit_message>
check: round 171 passed
</commit_message>
<xml_diff>
--- a/results/cell_ppt_edited/acceptance.pptx
+++ b/results/cell_ppt_edited/acceptance.pptx
@@ -236,7 +236,7 @@
           <a:bodyPr/>
           <a:lstStyle/>
           <a:p>
-            <a:fld id="{BE8087A8-B5D7-4357-AE59-6FD17618C1CA}" type="datetimeFigureOut">
+            <a:fld id="{DFC4F5E7-0A84-4768-8D36-3515A0B8AD04}" type="datetimeFigureOut">
               <a:rPr lang="zh-CN" altLang="en-US" smtClean="0"/>
               <a:t>2026/10/2</a:t>
             </a:fld>
@@ -278,7 +278,7 @@
           <a:bodyPr/>
           <a:lstStyle/>
           <a:p>
-            <a:fld id="{BBD35C1D-5E65-4137-BC2C-8F2F549B8297}" type="slidenum">
+            <a:fld id="{72EA7FEF-5E76-41E1-A1B3-114B99822EDF}" type="slidenum">
               <a:rPr lang="zh-CN" altLang="en-US" smtClean="0"/>
               <a:t>‹#›</a:t>
             </a:fld>
@@ -289,7 +289,7 @@
     </p:spTree>
     <p:extLst>
       <p:ext uri="{BB962C8B-B14F-4D97-AF65-F5344CB8AC3E}">
-        <p14:creationId xmlns:p14="http://schemas.microsoft.com/office/powerpoint/2010/main" val="2630955929"/>
+        <p14:creationId xmlns:p14="http://schemas.microsoft.com/office/powerpoint/2010/main" val="2766791796"/>
       </p:ext>
     </p:extLst>
   </p:cSld>
@@ -406,7 +406,7 @@
           <a:bodyPr/>
           <a:lstStyle/>
           <a:p>
-            <a:fld id="{BE8087A8-B5D7-4357-AE59-6FD17618C1CA}" type="datetimeFigureOut">
+            <a:fld id="{DFC4F5E7-0A84-4768-8D36-3515A0B8AD04}" type="datetimeFigureOut">
               <a:rPr lang="zh-CN" altLang="en-US" smtClean="0"/>
               <a:t>2026/10/2</a:t>
             </a:fld>
@@ -448,7 +448,7 @@
           <a:bodyPr/>
           <a:lstStyle/>
           <a:p>
-            <a:fld id="{BBD35C1D-5E65-4137-BC2C-8F2F549B8297}" type="slidenum">
+            <a:fld id="{72EA7FEF-5E76-41E1-A1B3-114B99822EDF}" type="slidenum">
               <a:rPr lang="zh-CN" altLang="en-US" smtClean="0"/>
               <a:t>‹#›</a:t>
             </a:fld>
@@ -459,7 +459,7 @@
     </p:spTree>
     <p:extLst>
       <p:ext uri="{BB962C8B-B14F-4D97-AF65-F5344CB8AC3E}">
-        <p14:creationId xmlns:p14="http://schemas.microsoft.com/office/powerpoint/2010/main" val="434466824"/>
+        <p14:creationId xmlns:p14="http://schemas.microsoft.com/office/powerpoint/2010/main" val="2290948905"/>
       </p:ext>
     </p:extLst>
   </p:cSld>
@@ -586,7 +586,7 @@
           <a:bodyPr/>
           <a:lstStyle/>
           <a:p>
-            <a:fld id="{BE8087A8-B5D7-4357-AE59-6FD17618C1CA}" type="datetimeFigureOut">
+            <a:fld id="{DFC4F5E7-0A84-4768-8D36-3515A0B8AD04}" type="datetimeFigureOut">
               <a:rPr lang="zh-CN" altLang="en-US" smtClean="0"/>
               <a:t>2026/10/2</a:t>
             </a:fld>
@@ -628,7 +628,7 @@
           <a:bodyPr/>
           <a:lstStyle/>
           <a:p>
-            <a:fld id="{BBD35C1D-5E65-4137-BC2C-8F2F549B8297}" type="slidenum">
+            <a:fld id="{72EA7FEF-5E76-41E1-A1B3-114B99822EDF}" type="slidenum">
               <a:rPr lang="zh-CN" altLang="en-US" smtClean="0"/>
               <a:t>‹#›</a:t>
             </a:fld>
@@ -639,7 +639,7 @@
     </p:spTree>
     <p:extLst>
       <p:ext uri="{BB962C8B-B14F-4D97-AF65-F5344CB8AC3E}">
-        <p14:creationId xmlns:p14="http://schemas.microsoft.com/office/powerpoint/2010/main" val="1042765240"/>
+        <p14:creationId xmlns:p14="http://schemas.microsoft.com/office/powerpoint/2010/main" val="939973056"/>
       </p:ext>
     </p:extLst>
   </p:cSld>
@@ -756,7 +756,7 @@
           <a:bodyPr/>
           <a:lstStyle/>
           <a:p>
-            <a:fld id="{BE8087A8-B5D7-4357-AE59-6FD17618C1CA}" type="datetimeFigureOut">
+            <a:fld id="{DFC4F5E7-0A84-4768-8D36-3515A0B8AD04}" type="datetimeFigureOut">
               <a:rPr lang="zh-CN" altLang="en-US" smtClean="0"/>
               <a:t>2026/10/2</a:t>
             </a:fld>
@@ -798,7 +798,7 @@
           <a:bodyPr/>
           <a:lstStyle/>
           <a:p>
-            <a:fld id="{BBD35C1D-5E65-4137-BC2C-8F2F549B8297}" type="slidenum">
+            <a:fld id="{72EA7FEF-5E76-41E1-A1B3-114B99822EDF}" type="slidenum">
               <a:rPr lang="zh-CN" altLang="en-US" smtClean="0"/>
               <a:t>‹#›</a:t>
             </a:fld>
@@ -809,7 +809,7 @@
     </p:spTree>
     <p:extLst>
       <p:ext uri="{BB962C8B-B14F-4D97-AF65-F5344CB8AC3E}">
-        <p14:creationId xmlns:p14="http://schemas.microsoft.com/office/powerpoint/2010/main" val="1346274400"/>
+        <p14:creationId xmlns:p14="http://schemas.microsoft.com/office/powerpoint/2010/main" val="2791774456"/>
       </p:ext>
     </p:extLst>
   </p:cSld>
@@ -1002,7 +1002,7 @@
           <a:bodyPr/>
           <a:lstStyle/>
           <a:p>
-            <a:fld id="{BE8087A8-B5D7-4357-AE59-6FD17618C1CA}" type="datetimeFigureOut">
+            <a:fld id="{DFC4F5E7-0A84-4768-8D36-3515A0B8AD04}" type="datetimeFigureOut">
               <a:rPr lang="zh-CN" altLang="en-US" smtClean="0"/>
               <a:t>2026/10/2</a:t>
             </a:fld>
@@ -1044,7 +1044,7 @@
           <a:bodyPr/>
           <a:lstStyle/>
           <a:p>
-            <a:fld id="{BBD35C1D-5E65-4137-BC2C-8F2F549B8297}" type="slidenum">
+            <a:fld id="{72EA7FEF-5E76-41E1-A1B3-114B99822EDF}" type="slidenum">
               <a:rPr lang="zh-CN" altLang="en-US" smtClean="0"/>
               <a:t>‹#›</a:t>
             </a:fld>
@@ -1055,7 +1055,7 @@
     </p:spTree>
     <p:extLst>
       <p:ext uri="{BB962C8B-B14F-4D97-AF65-F5344CB8AC3E}">
-        <p14:creationId xmlns:p14="http://schemas.microsoft.com/office/powerpoint/2010/main" val="3035954344"/>
+        <p14:creationId xmlns:p14="http://schemas.microsoft.com/office/powerpoint/2010/main" val="3298759323"/>
       </p:ext>
     </p:extLst>
   </p:cSld>
@@ -1234,7 +1234,7 @@
           <a:bodyPr/>
           <a:lstStyle/>
           <a:p>
-            <a:fld id="{BE8087A8-B5D7-4357-AE59-6FD17618C1CA}" type="datetimeFigureOut">
+            <a:fld id="{DFC4F5E7-0A84-4768-8D36-3515A0B8AD04}" type="datetimeFigureOut">
               <a:rPr lang="zh-CN" altLang="en-US" smtClean="0"/>
               <a:t>2026/10/2</a:t>
             </a:fld>
@@ -1276,7 +1276,7 @@
           <a:bodyPr/>
           <a:lstStyle/>
           <a:p>
-            <a:fld id="{BBD35C1D-5E65-4137-BC2C-8F2F549B8297}" type="slidenum">
+            <a:fld id="{72EA7FEF-5E76-41E1-A1B3-114B99822EDF}" type="slidenum">
               <a:rPr lang="zh-CN" altLang="en-US" smtClean="0"/>
               <a:t>‹#›</a:t>
             </a:fld>
@@ -1287,7 +1287,7 @@
     </p:spTree>
     <p:extLst>
       <p:ext uri="{BB962C8B-B14F-4D97-AF65-F5344CB8AC3E}">
-        <p14:creationId xmlns:p14="http://schemas.microsoft.com/office/powerpoint/2010/main" val="2293339222"/>
+        <p14:creationId xmlns:p14="http://schemas.microsoft.com/office/powerpoint/2010/main" val="263914873"/>
       </p:ext>
     </p:extLst>
   </p:cSld>
@@ -1601,7 +1601,7 @@
           <a:bodyPr/>
           <a:lstStyle/>
           <a:p>
-            <a:fld id="{BE8087A8-B5D7-4357-AE59-6FD17618C1CA}" type="datetimeFigureOut">
+            <a:fld id="{DFC4F5E7-0A84-4768-8D36-3515A0B8AD04}" type="datetimeFigureOut">
               <a:rPr lang="zh-CN" altLang="en-US" smtClean="0"/>
               <a:t>2026/10/2</a:t>
             </a:fld>
@@ -1643,7 +1643,7 @@
           <a:bodyPr/>
           <a:lstStyle/>
           <a:p>
-            <a:fld id="{BBD35C1D-5E65-4137-BC2C-8F2F549B8297}" type="slidenum">
+            <a:fld id="{72EA7FEF-5E76-41E1-A1B3-114B99822EDF}" type="slidenum">
               <a:rPr lang="zh-CN" altLang="en-US" smtClean="0"/>
               <a:t>‹#›</a:t>
             </a:fld>
@@ -1654,7 +1654,7 @@
     </p:spTree>
     <p:extLst>
       <p:ext uri="{BB962C8B-B14F-4D97-AF65-F5344CB8AC3E}">
-        <p14:creationId xmlns:p14="http://schemas.microsoft.com/office/powerpoint/2010/main" val="3892655281"/>
+        <p14:creationId xmlns:p14="http://schemas.microsoft.com/office/powerpoint/2010/main" val="3791484456"/>
       </p:ext>
     </p:extLst>
   </p:cSld>
@@ -1719,7 +1719,7 @@
           <a:bodyPr/>
           <a:lstStyle/>
           <a:p>
-            <a:fld id="{BE8087A8-B5D7-4357-AE59-6FD17618C1CA}" type="datetimeFigureOut">
+            <a:fld id="{DFC4F5E7-0A84-4768-8D36-3515A0B8AD04}" type="datetimeFigureOut">
               <a:rPr lang="zh-CN" altLang="en-US" smtClean="0"/>
               <a:t>2026/10/2</a:t>
             </a:fld>
@@ -1761,7 +1761,7 @@
           <a:bodyPr/>
           <a:lstStyle/>
           <a:p>
-            <a:fld id="{BBD35C1D-5E65-4137-BC2C-8F2F549B8297}" type="slidenum">
+            <a:fld id="{72EA7FEF-5E76-41E1-A1B3-114B99822EDF}" type="slidenum">
               <a:rPr lang="zh-CN" altLang="en-US" smtClean="0"/>
               <a:t>‹#›</a:t>
             </a:fld>
@@ -1772,7 +1772,7 @@
     </p:spTree>
     <p:extLst>
       <p:ext uri="{BB962C8B-B14F-4D97-AF65-F5344CB8AC3E}">
-        <p14:creationId xmlns:p14="http://schemas.microsoft.com/office/powerpoint/2010/main" val="2927468478"/>
+        <p14:creationId xmlns:p14="http://schemas.microsoft.com/office/powerpoint/2010/main" val="487852091"/>
       </p:ext>
     </p:extLst>
   </p:cSld>
@@ -1814,7 +1814,7 @@
           <a:bodyPr/>
           <a:lstStyle/>
           <a:p>
-            <a:fld id="{BE8087A8-B5D7-4357-AE59-6FD17618C1CA}" type="datetimeFigureOut">
+            <a:fld id="{DFC4F5E7-0A84-4768-8D36-3515A0B8AD04}" type="datetimeFigureOut">
               <a:rPr lang="zh-CN" altLang="en-US" smtClean="0"/>
               <a:t>2026/10/2</a:t>
             </a:fld>
@@ -1856,7 +1856,7 @@
           <a:bodyPr/>
           <a:lstStyle/>
           <a:p>
-            <a:fld id="{BBD35C1D-5E65-4137-BC2C-8F2F549B8297}" type="slidenum">
+            <a:fld id="{72EA7FEF-5E76-41E1-A1B3-114B99822EDF}" type="slidenum">
               <a:rPr lang="zh-CN" altLang="en-US" smtClean="0"/>
               <a:t>‹#›</a:t>
             </a:fld>
@@ -1867,7 +1867,7 @@
     </p:spTree>
     <p:extLst>
       <p:ext uri="{BB962C8B-B14F-4D97-AF65-F5344CB8AC3E}">
-        <p14:creationId xmlns:p14="http://schemas.microsoft.com/office/powerpoint/2010/main" val="3577161591"/>
+        <p14:creationId xmlns:p14="http://schemas.microsoft.com/office/powerpoint/2010/main" val="2730406071"/>
       </p:ext>
     </p:extLst>
   </p:cSld>
@@ -2091,7 +2091,7 @@
           <a:bodyPr/>
           <a:lstStyle/>
           <a:p>
-            <a:fld id="{BE8087A8-B5D7-4357-AE59-6FD17618C1CA}" type="datetimeFigureOut">
+            <a:fld id="{DFC4F5E7-0A84-4768-8D36-3515A0B8AD04}" type="datetimeFigureOut">
               <a:rPr lang="zh-CN" altLang="en-US" smtClean="0"/>
               <a:t>2026/10/2</a:t>
             </a:fld>
@@ -2133,7 +2133,7 @@
           <a:bodyPr/>
           <a:lstStyle/>
           <a:p>
-            <a:fld id="{BBD35C1D-5E65-4137-BC2C-8F2F549B8297}" type="slidenum">
+            <a:fld id="{72EA7FEF-5E76-41E1-A1B3-114B99822EDF}" type="slidenum">
               <a:rPr lang="zh-CN" altLang="en-US" smtClean="0"/>
               <a:t>‹#›</a:t>
             </a:fld>
@@ -2144,7 +2144,7 @@
     </p:spTree>
     <p:extLst>
       <p:ext uri="{BB962C8B-B14F-4D97-AF65-F5344CB8AC3E}">
-        <p14:creationId xmlns:p14="http://schemas.microsoft.com/office/powerpoint/2010/main" val="475292459"/>
+        <p14:creationId xmlns:p14="http://schemas.microsoft.com/office/powerpoint/2010/main" val="1835329971"/>
       </p:ext>
     </p:extLst>
   </p:cSld>
@@ -2344,7 +2344,7 @@
           <a:bodyPr/>
           <a:lstStyle/>
           <a:p>
-            <a:fld id="{BE8087A8-B5D7-4357-AE59-6FD17618C1CA}" type="datetimeFigureOut">
+            <a:fld id="{DFC4F5E7-0A84-4768-8D36-3515A0B8AD04}" type="datetimeFigureOut">
               <a:rPr lang="zh-CN" altLang="en-US" smtClean="0"/>
               <a:t>2026/10/2</a:t>
             </a:fld>
@@ -2386,7 +2386,7 @@
           <a:bodyPr/>
           <a:lstStyle/>
           <a:p>
-            <a:fld id="{BBD35C1D-5E65-4137-BC2C-8F2F549B8297}" type="slidenum">
+            <a:fld id="{72EA7FEF-5E76-41E1-A1B3-114B99822EDF}" type="slidenum">
               <a:rPr lang="zh-CN" altLang="en-US" smtClean="0"/>
               <a:t>‹#›</a:t>
             </a:fld>
@@ -2397,7 +2397,7 @@
     </p:spTree>
     <p:extLst>
       <p:ext uri="{BB962C8B-B14F-4D97-AF65-F5344CB8AC3E}">
-        <p14:creationId xmlns:p14="http://schemas.microsoft.com/office/powerpoint/2010/main" val="3890189469"/>
+        <p14:creationId xmlns:p14="http://schemas.microsoft.com/office/powerpoint/2010/main" val="2756762200"/>
       </p:ext>
     </p:extLst>
   </p:cSld>
@@ -2557,7 +2557,7 @@
             </a:lvl1pPr>
           </a:lstStyle>
           <a:p>
-            <a:fld id="{BE8087A8-B5D7-4357-AE59-6FD17618C1CA}" type="datetimeFigureOut">
+            <a:fld id="{DFC4F5E7-0A84-4768-8D36-3515A0B8AD04}" type="datetimeFigureOut">
               <a:rPr lang="zh-CN" altLang="en-US" smtClean="0"/>
               <a:t>2026/10/2</a:t>
             </a:fld>
@@ -2635,7 +2635,7 @@
             </a:lvl1pPr>
           </a:lstStyle>
           <a:p>
-            <a:fld id="{BBD35C1D-5E65-4137-BC2C-8F2F549B8297}" type="slidenum">
+            <a:fld id="{72EA7FEF-5E76-41E1-A1B3-114B99822EDF}" type="slidenum">
               <a:rPr lang="zh-CN" altLang="en-US" smtClean="0"/>
               <a:t>‹#›</a:t>
             </a:fld>
@@ -2646,7 +2646,7 @@
     </p:spTree>
     <p:extLst>
       <p:ext uri="{BB962C8B-B14F-4D97-AF65-F5344CB8AC3E}">
-        <p14:creationId xmlns:p14="http://schemas.microsoft.com/office/powerpoint/2010/main" val="433720497"/>
+        <p14:creationId xmlns:p14="http://schemas.microsoft.com/office/powerpoint/2010/main" val="4065311071"/>
       </p:ext>
     </p:extLst>
   </p:cSld>
@@ -3007,10 +3007,570 @@
           </a:p>
         </p:txBody>
       </p:sp>
+      <p:sp>
+        <p:nvSpPr>
+          <p:cNvPr id="3" name="cell0"/>
+          <p:cNvSpPr/>
+          <p:nvPr/>
+        </p:nvSpPr>
+        <p:spPr>
+          <a:xfrm>
+            <a:off x="635000" y="635000"/>
+            <a:ext cx="1270000" cy="1016000"/>
+          </a:xfrm>
+          <a:prstGeom prst="ellipse">
+            <a:avLst/>
+          </a:prstGeom>
+          <a:gradFill flip="none" rotWithShape="1">
+            <a:gsLst>
+              <a:gs pos="0">
+                <a:srgbClr val="FFF2CC"/>
+              </a:gs>
+              <a:gs pos="100000">
+                <a:srgbClr val="512173"/>
+              </a:gs>
+              <a:gs pos="40000">
+                <a:srgbClr val="A65BC4">
+                  <a:alpha val="80000"/>
+                </a:srgbClr>
+              </a:gs>
+            </a:gsLst>
+            <a:lin ang="2100000" scaled="1"/>
+            <a:tileRect/>
+          </a:gradFill>
+          <a:ln w="25400" cap="flat" cmpd="sng" algn="ctr">
+            <a:noFill/>
+            <a:prstDash val="solid"/>
+            <a:miter lim="800000"/>
+          </a:ln>
+          <a:effectLst/>
+          <a:extLst>
+            <a:ext uri="{91240B29-F687-4F45-9708-019B960494DF}">
+              <a14:hiddenLine xmlns:a14="http://schemas.microsoft.com/office/drawing/2010/main" w="25400" cap="flat" cmpd="sng" algn="ctr">
+                <a:solidFill>
+                  <a:srgbClr val="334455"/>
+                </a:solidFill>
+                <a:prstDash val="solid"/>
+                <a:miter lim="800000"/>
+              </a14:hiddenLine>
+            </a:ext>
+          </a:extLst>
+        </p:spPr>
+        <p:style>
+          <a:lnRef idx="2">
+            <a:schemeClr val="accent1">
+              <a:shade val="50000"/>
+            </a:schemeClr>
+          </a:lnRef>
+          <a:fillRef idx="1">
+            <a:schemeClr val="accent1"/>
+          </a:fillRef>
+          <a:effectRef idx="0">
+            <a:schemeClr val="accent1"/>
+          </a:effectRef>
+          <a:fontRef idx="minor">
+            <a:schemeClr val="lt1"/>
+          </a:fontRef>
+        </p:style>
+        <p:txBody>
+          <a:bodyPr rtlCol="0" anchor="ctr"/>
+          <a:lstStyle/>
+          <a:p>
+            <a:pPr algn="ctr"/>
+            <a:endParaRPr lang="zh-CN" altLang="en-US"/>
+          </a:p>
+        </p:txBody>
+      </p:sp>
+      <p:sp>
+        <p:nvSpPr>
+          <p:cNvPr id="4" name="cell1"/>
+          <p:cNvSpPr/>
+          <p:nvPr/>
+        </p:nvSpPr>
+        <p:spPr>
+          <a:xfrm>
+            <a:off x="2286000" y="635000"/>
+            <a:ext cx="1270000" cy="1016000"/>
+          </a:xfrm>
+          <a:prstGeom prst="ellipse">
+            <a:avLst/>
+          </a:prstGeom>
+          <a:gradFill flip="none" rotWithShape="1">
+            <a:gsLst>
+              <a:gs pos="0">
+                <a:srgbClr val="FFF2CC"/>
+              </a:gs>
+              <a:gs pos="100000">
+                <a:srgbClr val="512173"/>
+              </a:gs>
+              <a:gs pos="40000">
+                <a:srgbClr val="A65BC4">
+                  <a:alpha val="80000"/>
+                </a:srgbClr>
+              </a:gs>
+            </a:gsLst>
+            <a:path path="rect">
+              <a:fillToRect l="50000" t="50000" r="50000" b="50000"/>
+            </a:path>
+            <a:tileRect/>
+          </a:gradFill>
+          <a:ln w="12700" cap="flat" cmpd="sng" algn="ctr">
+            <a:noFill/>
+            <a:prstDash val="solid"/>
+            <a:miter lim="800000"/>
+          </a:ln>
+          <a:effectLst/>
+          <a:extLst>
+            <a:ext uri="{91240B29-F687-4F45-9708-019B960494DF}">
+              <a14:hiddenLine xmlns:a14="http://schemas.microsoft.com/office/drawing/2010/main" w="12700" cap="flat" cmpd="sng" algn="ctr">
+                <a:solidFill>
+                  <a:schemeClr val="accent1">
+                    <a:shade val="50000"/>
+                  </a:schemeClr>
+                </a:solidFill>
+                <a:prstDash val="solid"/>
+                <a:miter lim="800000"/>
+              </a14:hiddenLine>
+            </a:ext>
+          </a:extLst>
+        </p:spPr>
+        <p:style>
+          <a:lnRef idx="2">
+            <a:schemeClr val="accent1">
+              <a:shade val="50000"/>
+            </a:schemeClr>
+          </a:lnRef>
+          <a:fillRef idx="1">
+            <a:schemeClr val="accent1"/>
+          </a:fillRef>
+          <a:effectRef idx="0">
+            <a:schemeClr val="accent1"/>
+          </a:effectRef>
+          <a:fontRef idx="minor">
+            <a:schemeClr val="lt1"/>
+          </a:fontRef>
+        </p:style>
+        <p:txBody>
+          <a:bodyPr rtlCol="0" anchor="ctr"/>
+          <a:lstStyle/>
+          <a:p>
+            <a:pPr algn="ctr"/>
+            <a:endParaRPr lang="zh-CN" altLang="en-US"/>
+          </a:p>
+        </p:txBody>
+      </p:sp>
+      <p:sp>
+        <p:nvSpPr>
+          <p:cNvPr id="5" name="cell2"/>
+          <p:cNvSpPr/>
+          <p:nvPr/>
+        </p:nvSpPr>
+        <p:spPr>
+          <a:xfrm>
+            <a:off x="3937000" y="635000"/>
+            <a:ext cx="1270000" cy="1016000"/>
+          </a:xfrm>
+          <a:prstGeom prst="ellipse">
+            <a:avLst/>
+          </a:prstGeom>
+          <a:gradFill flip="none" rotWithShape="1">
+            <a:gsLst>
+              <a:gs pos="0">
+                <a:srgbClr val="FFF2CC"/>
+              </a:gs>
+              <a:gs pos="100000">
+                <a:srgbClr val="512173"/>
+              </a:gs>
+              <a:gs pos="40000">
+                <a:srgbClr val="A65BC4">
+                  <a:alpha val="80000"/>
+                </a:srgbClr>
+              </a:gs>
+            </a:gsLst>
+            <a:path path="rect">
+              <a:fillToRect r="100000" b="100000"/>
+            </a:path>
+            <a:tileRect l="-100000" t="-100000"/>
+          </a:gradFill>
+          <a:ln w="12700" cap="flat" cmpd="sng" algn="ctr">
+            <a:noFill/>
+            <a:prstDash val="solid"/>
+            <a:miter lim="800000"/>
+          </a:ln>
+          <a:effectLst/>
+          <a:extLst>
+            <a:ext uri="{91240B29-F687-4F45-9708-019B960494DF}">
+              <a14:hiddenLine xmlns:a14="http://schemas.microsoft.com/office/drawing/2010/main" w="12700" cap="flat" cmpd="sng" algn="ctr">
+                <a:solidFill>
+                  <a:schemeClr val="accent1">
+                    <a:shade val="50000"/>
+                  </a:schemeClr>
+                </a:solidFill>
+                <a:prstDash val="solid"/>
+                <a:miter lim="800000"/>
+              </a14:hiddenLine>
+            </a:ext>
+          </a:extLst>
+        </p:spPr>
+        <p:style>
+          <a:lnRef idx="2">
+            <a:schemeClr val="accent1">
+              <a:shade val="50000"/>
+            </a:schemeClr>
+          </a:lnRef>
+          <a:fillRef idx="1">
+            <a:schemeClr val="accent1"/>
+          </a:fillRef>
+          <a:effectRef idx="0">
+            <a:schemeClr val="accent1"/>
+          </a:effectRef>
+          <a:fontRef idx="minor">
+            <a:schemeClr val="lt1"/>
+          </a:fontRef>
+        </p:style>
+        <p:txBody>
+          <a:bodyPr rtlCol="0" anchor="ctr"/>
+          <a:lstStyle/>
+          <a:p>
+            <a:pPr algn="ctr"/>
+            <a:endParaRPr lang="zh-CN" altLang="en-US"/>
+          </a:p>
+        </p:txBody>
+      </p:sp>
+      <p:sp>
+        <p:nvSpPr>
+          <p:cNvPr id="9" name="curve"/>
+          <p:cNvSpPr/>
+          <p:nvPr/>
+        </p:nvSpPr>
+        <p:spPr>
+          <a:xfrm>
+            <a:off x="762000" y="3175000"/>
+            <a:ext cx="3175000" cy="508000"/>
+          </a:xfrm>
+          <a:custGeom>
+            <a:avLst/>
+            <a:gdLst>
+              <a:gd name="connsiteX0" fmla="*/ 0 w 3175000"/>
+              <a:gd name="connsiteY0" fmla="*/ 381000 h 508000"/>
+              <a:gd name="connsiteX1" fmla="*/ 2540000 w 3175000"/>
+              <a:gd name="connsiteY1" fmla="*/ 0 h 508000"/>
+              <a:gd name="connsiteX2" fmla="*/ 3175000 w 3175000"/>
+              <a:gd name="connsiteY2" fmla="*/ 508000 h 508000"/>
+              <a:gd name="connsiteX0" fmla="*/ 0 w 3556000"/>
+              <a:gd name="connsiteY0" fmla="*/ 381000 h 508000"/>
+              <a:gd name="connsiteX1" fmla="*/ 2540000 w 3556000"/>
+              <a:gd name="connsiteY1" fmla="*/ 0 h 508000"/>
+              <a:gd name="connsiteX2" fmla="*/ 3175000 w 3556000"/>
+              <a:gd name="connsiteY2" fmla="*/ 508000 h 508000"/>
+              <a:gd name="connsiteX3" fmla="*/ 3556000 w 3556000"/>
+              <a:gd name="connsiteY3" fmla="*/ 0 h 508000"/>
+              <a:gd name="connsiteX0" fmla="*/ 0 w 3175000"/>
+              <a:gd name="connsiteY0" fmla="*/ 381000 h 508000"/>
+              <a:gd name="connsiteX1" fmla="*/ 2540000 w 3175000"/>
+              <a:gd name="connsiteY1" fmla="*/ 0 h 508000"/>
+              <a:gd name="connsiteX2" fmla="*/ 3175000 w 3175000"/>
+              <a:gd name="connsiteY2" fmla="*/ 508000 h 508000"/>
+              <a:gd name="connsiteX0" fmla="*/ 0 w 3175000"/>
+              <a:gd name="connsiteY0" fmla="*/ 381000 h 508000"/>
+              <a:gd name="connsiteX1" fmla="*/ 2540000 w 3175000"/>
+              <a:gd name="connsiteY1" fmla="*/ 0 h 508000"/>
+              <a:gd name="connsiteX2" fmla="*/ 3175000 w 3175000"/>
+              <a:gd name="connsiteY2" fmla="*/ 508000 h 508000"/>
+            </a:gdLst>
+            <a:ahLst/>
+            <a:cxnLst>
+              <a:cxn ang="0">
+                <a:pos x="connsiteX0" y="connsiteY0"/>
+              </a:cxn>
+              <a:cxn ang="0">
+                <a:pos x="connsiteX1" y="connsiteY1"/>
+              </a:cxn>
+              <a:cxn ang="0">
+                <a:pos x="connsiteX2" y="connsiteY2"/>
+              </a:cxn>
+            </a:cxnLst>
+            <a:rect l="l" t="t" r="r" b="b"/>
+            <a:pathLst>
+              <a:path w="3175000" h="508000">
+                <a:moveTo>
+                  <a:pt x="0" y="381000"/>
+                </a:moveTo>
+                <a:cubicBezTo>
+                  <a:pt x="635000" y="-762000"/>
+                  <a:pt x="1905000" y="1270000"/>
+                  <a:pt x="2540000" y="0"/>
+                </a:cubicBezTo>
+                <a:lnTo>
+                  <a:pt x="3175000" y="508000"/>
+                </a:lnTo>
+              </a:path>
+            </a:pathLst>
+          </a:custGeom>
+          <a:ln w="50800">
+            <a:solidFill>
+              <a:srgbClr val="7030A0"/>
+            </a:solidFill>
+          </a:ln>
+        </p:spPr>
+        <p:style>
+          <a:lnRef idx="1">
+            <a:schemeClr val="accent1"/>
+          </a:lnRef>
+          <a:fillRef idx="0">
+            <a:schemeClr val="accent1"/>
+          </a:fillRef>
+          <a:effectRef idx="0">
+            <a:schemeClr val="accent1"/>
+          </a:effectRef>
+          <a:fontRef idx="minor">
+            <a:schemeClr val="tx1"/>
+          </a:fontRef>
+        </p:style>
+        <p:txBody>
+          <a:bodyPr rtlCol="0" anchor="ctr"/>
+          <a:lstStyle/>
+          <a:p>
+            <a:pPr algn="ctr"/>
+            <a:endParaRPr lang="zh-CN" altLang="en-US"/>
+          </a:p>
+        </p:txBody>
+      </p:sp>
+      <p:sp>
+        <p:nvSpPr>
+          <p:cNvPr id="10" name="convert_path"/>
+          <p:cNvSpPr/>
+          <p:nvPr/>
+        </p:nvSpPr>
+        <p:spPr>
+          <a:xfrm>
+            <a:off x="5080000" y="2921000"/>
+            <a:ext cx="1524000" cy="381000"/>
+          </a:xfrm>
+          <a:custGeom>
+            <a:avLst/>
+            <a:gdLst>
+              <a:gd name="connsiteX0" fmla="*/ 0 w 1524000"/>
+              <a:gd name="connsiteY0" fmla="*/ 0 h 381000"/>
+              <a:gd name="connsiteX1" fmla="*/ 762000 w 1524000"/>
+              <a:gd name="connsiteY1" fmla="*/ 381000 h 381000"/>
+              <a:gd name="connsiteX2" fmla="*/ 1524000 w 1524000"/>
+              <a:gd name="connsiteY2" fmla="*/ 0 h 381000"/>
+            </a:gdLst>
+            <a:ahLst/>
+            <a:cxnLst>
+              <a:cxn ang="0">
+                <a:pos x="connsiteX0" y="connsiteY0"/>
+              </a:cxn>
+              <a:cxn ang="0">
+                <a:pos x="connsiteX1" y="connsiteY1"/>
+              </a:cxn>
+              <a:cxn ang="0">
+                <a:pos x="connsiteX2" y="connsiteY2"/>
+              </a:cxn>
+            </a:cxnLst>
+            <a:rect l="l" t="t" r="r" b="b"/>
+            <a:pathLst>
+              <a:path w="1524000" h="381000">
+                <a:moveTo>
+                  <a:pt x="0" y="0"/>
+                </a:moveTo>
+                <a:cubicBezTo>
+                  <a:pt x="254000" y="127000"/>
+                  <a:pt x="508000" y="254000"/>
+                  <a:pt x="762000" y="381000"/>
+                </a:cubicBezTo>
+                <a:lnTo>
+                  <a:pt x="1524000" y="0"/>
+                </a:lnTo>
+              </a:path>
+            </a:pathLst>
+          </a:custGeom>
+          <a:ln w="38100">
+            <a:solidFill>
+              <a:srgbClr val="3388AA"/>
+            </a:solidFill>
+          </a:ln>
+        </p:spPr>
+        <p:style>
+          <a:lnRef idx="1">
+            <a:schemeClr val="accent1"/>
+          </a:lnRef>
+          <a:fillRef idx="0">
+            <a:schemeClr val="accent1"/>
+          </a:fillRef>
+          <a:effectRef idx="0">
+            <a:schemeClr val="accent1"/>
+          </a:effectRef>
+          <a:fontRef idx="minor">
+            <a:schemeClr val="tx1"/>
+          </a:fontRef>
+        </p:style>
+        <p:txBody>
+          <a:bodyPr rtlCol="0" anchor="ctr"/>
+          <a:lstStyle/>
+          <a:p>
+            <a:pPr algn="ctr"/>
+            <a:endParaRPr lang="zh-CN" altLang="en-US"/>
+          </a:p>
+        </p:txBody>
+      </p:sp>
+      <p:sp>
+        <p:nvSpPr>
+          <p:cNvPr id="11" name="label"/>
+          <p:cNvSpPr txBox="1"/>
+          <p:nvPr/>
+        </p:nvSpPr>
+        <p:spPr>
+          <a:xfrm>
+            <a:off x="635000" y="4445000"/>
+            <a:ext cx="10033000" cy="964367"/>
+          </a:xfrm>
+          <a:prstGeom prst="rect">
+            <a:avLst/>
+          </a:prstGeom>
+          <a:noFill/>
+        </p:spPr>
+        <p:txBody>
+          <a:bodyPr vert="horz" rtlCol="0">
+            <a:spAutoFit/>
+          </a:bodyPr>
+          <a:lstStyle/>
+          <a:p>
+            <a:r>
+              <a:rPr lang="pt-BR" altLang="zh-CN" sz="2600" smtClean="0">
+                <a:solidFill>
+                  <a:srgbClr val="334455"/>
+                </a:solidFill>
+                <a:latin typeface="Arial" panose="020B0604020202020204" pitchFamily="34" charset="0"/>
+                <a:ea typeface="Microsoft YaHei" panose="020B0503020204020204" pitchFamily="34" charset="-122"/>
+              </a:rPr>
+              <a:t>H</a:t>
+            </a:r>
+            <a:r>
+              <a:rPr lang="pt-BR" altLang="zh-CN" sz="2400" baseline="-25000" smtClean="0">
+                <a:solidFill>
+                  <a:srgbClr val="334455"/>
+                </a:solidFill>
+                <a:latin typeface="Arial" panose="020B0604020202020204" pitchFamily="34" charset="0"/>
+                <a:ea typeface="Microsoft YaHei" panose="020B0503020204020204" pitchFamily="34" charset="-122"/>
+              </a:rPr>
+              <a:t>2</a:t>
+            </a:r>
+            <a:r>
+              <a:rPr lang="pt-BR" altLang="zh-CN" sz="2400" smtClean="0">
+                <a:solidFill>
+                  <a:srgbClr val="334455"/>
+                </a:solidFill>
+                <a:latin typeface="Arial" panose="020B0604020202020204" pitchFamily="34" charset="0"/>
+                <a:ea typeface="Microsoft YaHei" panose="020B0503020204020204" pitchFamily="34" charset="-122"/>
+              </a:rPr>
+              <a:t>O  ·  Ca</a:t>
+            </a:r>
+            <a:r>
+              <a:rPr lang="pt-BR" altLang="zh-CN" sz="2400" baseline="30000" smtClean="0">
+                <a:solidFill>
+                  <a:srgbClr val="7030A0"/>
+                </a:solidFill>
+                <a:latin typeface="Arial" panose="020B0604020202020204" pitchFamily="34" charset="0"/>
+                <a:ea typeface="Microsoft YaHei" panose="020B0503020204020204" pitchFamily="34" charset="-122"/>
+              </a:rPr>
+              <a:t>2+</a:t>
+            </a:r>
+            <a:r>
+              <a:rPr lang="pt-BR" altLang="zh-CN" sz="2400" i="1" smtClean="0">
+                <a:solidFill>
+                  <a:srgbClr val="334455"/>
+                </a:solidFill>
+                <a:latin typeface="Arial" panose="020B0604020202020204" pitchFamily="34" charset="0"/>
+                <a:ea typeface="Microsoft YaHei" panose="020B0503020204020204" pitchFamily="34" charset="-122"/>
+              </a:rPr>
+              <a:t>  </a:t>
+            </a:r>
+            <a:r>
+              <a:rPr lang="zh-CN" altLang="pt-BR" sz="2400" i="1" smtClean="0">
+                <a:solidFill>
+                  <a:srgbClr val="334455"/>
+                </a:solidFill>
+                <a:latin typeface="Arial" panose="020B0604020202020204" pitchFamily="34" charset="0"/>
+                <a:ea typeface="Microsoft YaHei" panose="020B0503020204020204" pitchFamily="34" charset="-122"/>
+              </a:rPr>
+              <a:t>🧬 </a:t>
+            </a:r>
+            <a:r>
+              <a:rPr lang="pt-BR" altLang="zh-CN" sz="2400" i="1" smtClean="0">
+                <a:solidFill>
+                  <a:srgbClr val="334455"/>
+                </a:solidFill>
+                <a:latin typeface="Arial" panose="020B0604020202020204" pitchFamily="34" charset="0"/>
+                <a:ea typeface="Microsoft YaHei" panose="020B0503020204020204" pitchFamily="34" charset="-122"/>
+              </a:rPr>
+              <a:t>DNA</a:t>
+            </a:r>
+          </a:p>
+          <a:p>
+            <a:pPr marL="457200" indent="-457200">
+              <a:spcBef>
+                <a:spcPts val="800"/>
+              </a:spcBef>
+              <a:buFont typeface="+mj-lt"/>
+              <a:buAutoNum type="arabicPeriod"/>
+            </a:pPr>
+            <a:r>
+              <a:rPr lang="zh-CN" altLang="pt-BR" sz="2400" smtClean="0">
+                <a:solidFill>
+                  <a:srgbClr val="334455"/>
+                </a:solidFill>
+                <a:latin typeface="Arial" panose="020B0604020202020204" pitchFamily="34" charset="0"/>
+                <a:ea typeface="Microsoft YaHei" panose="020B0503020204020204" pitchFamily="34" charset="-122"/>
+              </a:rPr>
+              <a:t>中文 </a:t>
+            </a:r>
+            <a:r>
+              <a:rPr lang="pt-BR" altLang="zh-CN" sz="2400" smtClean="0">
+                <a:solidFill>
+                  <a:srgbClr val="334455"/>
+                </a:solidFill>
+                <a:latin typeface="Arial" panose="020B0604020202020204" pitchFamily="34" charset="0"/>
+                <a:ea typeface="Microsoft YaHei" panose="020B0503020204020204" pitchFamily="34" charset="-122"/>
+              </a:rPr>
+              <a:t>/ English  </a:t>
+            </a:r>
+            <a:r>
+              <a:rPr lang="pt-BR" altLang="zh-CN" sz="2400" u="sng" smtClean="0">
+                <a:solidFill>
+                  <a:srgbClr val="334455"/>
+                </a:solidFill>
+                <a:latin typeface="Arial" panose="020B0604020202020204" pitchFamily="34" charset="0"/>
+                <a:ea typeface="Microsoft YaHei" panose="020B0503020204020204" pitchFamily="34" charset="-122"/>
+                <a:hlinkClick r:id="rId2"/>
+              </a:rPr>
+              <a:t>link</a:t>
+            </a:r>
+            <a:r>
+              <a:rPr lang="pt-BR" altLang="zh-CN" sz="2400" u="sng" smtClean="0">
+                <a:solidFill>
+                  <a:srgbClr val="334455"/>
+                </a:solidFill>
+                <a:latin typeface="Arial" panose="020B0604020202020204" pitchFamily="34" charset="0"/>
+                <a:ea typeface="Microsoft YaHei" panose="020B0503020204020204" pitchFamily="34" charset="-122"/>
+              </a:rPr>
+              <a:t> ✓</a:t>
+            </a:r>
+            <a:endParaRPr lang="zh-CN" altLang="en-US" sz="2400" i="1" u="sng">
+              <a:solidFill>
+                <a:srgbClr val="007799"/>
+              </a:solidFill>
+              <a:latin typeface="Arial" panose="020B0604020202020204" pitchFamily="34" charset="0"/>
+              <a:ea typeface="Microsoft YaHei" panose="020B0503020204020204" pitchFamily="34" charset="-122"/>
+            </a:endParaRPr>
+          </a:p>
+        </p:txBody>
+      </p:sp>
     </p:spTree>
     <p:extLst>
       <p:ext uri="{BB962C8B-B14F-4D97-AF65-F5344CB8AC3E}">
-        <p14:creationId xmlns:p14="http://schemas.microsoft.com/office/powerpoint/2010/main" val="1156693805"/>
+        <p14:creationId xmlns:p14="http://schemas.microsoft.com/office/powerpoint/2010/main" val="45927537"/>
       </p:ext>
     </p:extLst>
   </p:cSld>

</xml_diff>

<commit_message>
report: cell_ppt_edited desktop test PASSED 28/28 - restore fresh r171 artifacts from round commit bfa0c89 (loop-closed commit had reverted tracked-file updates) + final REPORT.md with root-cause analysis
Co-authored-by: arena-agent <297053741+arena-agent@users.noreply.github.com>
</commit_message>
<xml_diff>
--- a/results/cell_ppt_edited/acceptance.pptx
+++ b/results/cell_ppt_edited/acceptance.pptx
@@ -236,7 +236,7 @@
           <a:bodyPr/>
           <a:lstStyle/>
           <a:p>
-            <a:fld id="{BE8087A8-B5D7-4357-AE59-6FD17618C1CA}" type="datetimeFigureOut">
+            <a:fld id="{DFC4F5E7-0A84-4768-8D36-3515A0B8AD04}" type="datetimeFigureOut">
               <a:rPr lang="zh-CN" altLang="en-US" smtClean="0"/>
               <a:t>2026/10/2</a:t>
             </a:fld>
@@ -278,7 +278,7 @@
           <a:bodyPr/>
           <a:lstStyle/>
           <a:p>
-            <a:fld id="{BBD35C1D-5E65-4137-BC2C-8F2F549B8297}" type="slidenum">
+            <a:fld id="{72EA7FEF-5E76-41E1-A1B3-114B99822EDF}" type="slidenum">
               <a:rPr lang="zh-CN" altLang="en-US" smtClean="0"/>
               <a:t>‹#›</a:t>
             </a:fld>
@@ -289,7 +289,7 @@
     </p:spTree>
     <p:extLst>
       <p:ext uri="{BB962C8B-B14F-4D97-AF65-F5344CB8AC3E}">
-        <p14:creationId xmlns:p14="http://schemas.microsoft.com/office/powerpoint/2010/main" val="2630955929"/>
+        <p14:creationId xmlns:p14="http://schemas.microsoft.com/office/powerpoint/2010/main" val="2766791796"/>
       </p:ext>
     </p:extLst>
   </p:cSld>
@@ -406,7 +406,7 @@
           <a:bodyPr/>
           <a:lstStyle/>
           <a:p>
-            <a:fld id="{BE8087A8-B5D7-4357-AE59-6FD17618C1CA}" type="datetimeFigureOut">
+            <a:fld id="{DFC4F5E7-0A84-4768-8D36-3515A0B8AD04}" type="datetimeFigureOut">
               <a:rPr lang="zh-CN" altLang="en-US" smtClean="0"/>
               <a:t>2026/10/2</a:t>
             </a:fld>
@@ -448,7 +448,7 @@
           <a:bodyPr/>
           <a:lstStyle/>
           <a:p>
-            <a:fld id="{BBD35C1D-5E65-4137-BC2C-8F2F549B8297}" type="slidenum">
+            <a:fld id="{72EA7FEF-5E76-41E1-A1B3-114B99822EDF}" type="slidenum">
               <a:rPr lang="zh-CN" altLang="en-US" smtClean="0"/>
               <a:t>‹#›</a:t>
             </a:fld>
@@ -459,7 +459,7 @@
     </p:spTree>
     <p:extLst>
       <p:ext uri="{BB962C8B-B14F-4D97-AF65-F5344CB8AC3E}">
-        <p14:creationId xmlns:p14="http://schemas.microsoft.com/office/powerpoint/2010/main" val="434466824"/>
+        <p14:creationId xmlns:p14="http://schemas.microsoft.com/office/powerpoint/2010/main" val="2290948905"/>
       </p:ext>
     </p:extLst>
   </p:cSld>
@@ -586,7 +586,7 @@
           <a:bodyPr/>
           <a:lstStyle/>
           <a:p>
-            <a:fld id="{BE8087A8-B5D7-4357-AE59-6FD17618C1CA}" type="datetimeFigureOut">
+            <a:fld id="{DFC4F5E7-0A84-4768-8D36-3515A0B8AD04}" type="datetimeFigureOut">
               <a:rPr lang="zh-CN" altLang="en-US" smtClean="0"/>
               <a:t>2026/10/2</a:t>
             </a:fld>
@@ -628,7 +628,7 @@
           <a:bodyPr/>
           <a:lstStyle/>
           <a:p>
-            <a:fld id="{BBD35C1D-5E65-4137-BC2C-8F2F549B8297}" type="slidenum">
+            <a:fld id="{72EA7FEF-5E76-41E1-A1B3-114B99822EDF}" type="slidenum">
               <a:rPr lang="zh-CN" altLang="en-US" smtClean="0"/>
               <a:t>‹#›</a:t>
             </a:fld>
@@ -639,7 +639,7 @@
     </p:spTree>
     <p:extLst>
       <p:ext uri="{BB962C8B-B14F-4D97-AF65-F5344CB8AC3E}">
-        <p14:creationId xmlns:p14="http://schemas.microsoft.com/office/powerpoint/2010/main" val="1042765240"/>
+        <p14:creationId xmlns:p14="http://schemas.microsoft.com/office/powerpoint/2010/main" val="939973056"/>
       </p:ext>
     </p:extLst>
   </p:cSld>
@@ -756,7 +756,7 @@
           <a:bodyPr/>
           <a:lstStyle/>
           <a:p>
-            <a:fld id="{BE8087A8-B5D7-4357-AE59-6FD17618C1CA}" type="datetimeFigureOut">
+            <a:fld id="{DFC4F5E7-0A84-4768-8D36-3515A0B8AD04}" type="datetimeFigureOut">
               <a:rPr lang="zh-CN" altLang="en-US" smtClean="0"/>
               <a:t>2026/10/2</a:t>
             </a:fld>
@@ -798,7 +798,7 @@
           <a:bodyPr/>
           <a:lstStyle/>
           <a:p>
-            <a:fld id="{BBD35C1D-5E65-4137-BC2C-8F2F549B8297}" type="slidenum">
+            <a:fld id="{72EA7FEF-5E76-41E1-A1B3-114B99822EDF}" type="slidenum">
               <a:rPr lang="zh-CN" altLang="en-US" smtClean="0"/>
               <a:t>‹#›</a:t>
             </a:fld>
@@ -809,7 +809,7 @@
     </p:spTree>
     <p:extLst>
       <p:ext uri="{BB962C8B-B14F-4D97-AF65-F5344CB8AC3E}">
-        <p14:creationId xmlns:p14="http://schemas.microsoft.com/office/powerpoint/2010/main" val="1346274400"/>
+        <p14:creationId xmlns:p14="http://schemas.microsoft.com/office/powerpoint/2010/main" val="2791774456"/>
       </p:ext>
     </p:extLst>
   </p:cSld>
@@ -1002,7 +1002,7 @@
           <a:bodyPr/>
           <a:lstStyle/>
           <a:p>
-            <a:fld id="{BE8087A8-B5D7-4357-AE59-6FD17618C1CA}" type="datetimeFigureOut">
+            <a:fld id="{DFC4F5E7-0A84-4768-8D36-3515A0B8AD04}" type="datetimeFigureOut">
               <a:rPr lang="zh-CN" altLang="en-US" smtClean="0"/>
               <a:t>2026/10/2</a:t>
             </a:fld>
@@ -1044,7 +1044,7 @@
           <a:bodyPr/>
           <a:lstStyle/>
           <a:p>
-            <a:fld id="{BBD35C1D-5E65-4137-BC2C-8F2F549B8297}" type="slidenum">
+            <a:fld id="{72EA7FEF-5E76-41E1-A1B3-114B99822EDF}" type="slidenum">
               <a:rPr lang="zh-CN" altLang="en-US" smtClean="0"/>
               <a:t>‹#›</a:t>
             </a:fld>
@@ -1055,7 +1055,7 @@
     </p:spTree>
     <p:extLst>
       <p:ext uri="{BB962C8B-B14F-4D97-AF65-F5344CB8AC3E}">
-        <p14:creationId xmlns:p14="http://schemas.microsoft.com/office/powerpoint/2010/main" val="3035954344"/>
+        <p14:creationId xmlns:p14="http://schemas.microsoft.com/office/powerpoint/2010/main" val="3298759323"/>
       </p:ext>
     </p:extLst>
   </p:cSld>
@@ -1234,7 +1234,7 @@
           <a:bodyPr/>
           <a:lstStyle/>
           <a:p>
-            <a:fld id="{BE8087A8-B5D7-4357-AE59-6FD17618C1CA}" type="datetimeFigureOut">
+            <a:fld id="{DFC4F5E7-0A84-4768-8D36-3515A0B8AD04}" type="datetimeFigureOut">
               <a:rPr lang="zh-CN" altLang="en-US" smtClean="0"/>
               <a:t>2026/10/2</a:t>
             </a:fld>
@@ -1276,7 +1276,7 @@
           <a:bodyPr/>
           <a:lstStyle/>
           <a:p>
-            <a:fld id="{BBD35C1D-5E65-4137-BC2C-8F2F549B8297}" type="slidenum">
+            <a:fld id="{72EA7FEF-5E76-41E1-A1B3-114B99822EDF}" type="slidenum">
               <a:rPr lang="zh-CN" altLang="en-US" smtClean="0"/>
               <a:t>‹#›</a:t>
             </a:fld>
@@ -1287,7 +1287,7 @@
     </p:spTree>
     <p:extLst>
       <p:ext uri="{BB962C8B-B14F-4D97-AF65-F5344CB8AC3E}">
-        <p14:creationId xmlns:p14="http://schemas.microsoft.com/office/powerpoint/2010/main" val="2293339222"/>
+        <p14:creationId xmlns:p14="http://schemas.microsoft.com/office/powerpoint/2010/main" val="263914873"/>
       </p:ext>
     </p:extLst>
   </p:cSld>
@@ -1601,7 +1601,7 @@
           <a:bodyPr/>
           <a:lstStyle/>
           <a:p>
-            <a:fld id="{BE8087A8-B5D7-4357-AE59-6FD17618C1CA}" type="datetimeFigureOut">
+            <a:fld id="{DFC4F5E7-0A84-4768-8D36-3515A0B8AD04}" type="datetimeFigureOut">
               <a:rPr lang="zh-CN" altLang="en-US" smtClean="0"/>
               <a:t>2026/10/2</a:t>
             </a:fld>
@@ -1643,7 +1643,7 @@
           <a:bodyPr/>
           <a:lstStyle/>
           <a:p>
-            <a:fld id="{BBD35C1D-5E65-4137-BC2C-8F2F549B8297}" type="slidenum">
+            <a:fld id="{72EA7FEF-5E76-41E1-A1B3-114B99822EDF}" type="slidenum">
               <a:rPr lang="zh-CN" altLang="en-US" smtClean="0"/>
               <a:t>‹#›</a:t>
             </a:fld>
@@ -1654,7 +1654,7 @@
     </p:spTree>
     <p:extLst>
       <p:ext uri="{BB962C8B-B14F-4D97-AF65-F5344CB8AC3E}">
-        <p14:creationId xmlns:p14="http://schemas.microsoft.com/office/powerpoint/2010/main" val="3892655281"/>
+        <p14:creationId xmlns:p14="http://schemas.microsoft.com/office/powerpoint/2010/main" val="3791484456"/>
       </p:ext>
     </p:extLst>
   </p:cSld>
@@ -1719,7 +1719,7 @@
           <a:bodyPr/>
           <a:lstStyle/>
           <a:p>
-            <a:fld id="{BE8087A8-B5D7-4357-AE59-6FD17618C1CA}" type="datetimeFigureOut">
+            <a:fld id="{DFC4F5E7-0A84-4768-8D36-3515A0B8AD04}" type="datetimeFigureOut">
               <a:rPr lang="zh-CN" altLang="en-US" smtClean="0"/>
               <a:t>2026/10/2</a:t>
             </a:fld>
@@ -1761,7 +1761,7 @@
           <a:bodyPr/>
           <a:lstStyle/>
           <a:p>
-            <a:fld id="{BBD35C1D-5E65-4137-BC2C-8F2F549B8297}" type="slidenum">
+            <a:fld id="{72EA7FEF-5E76-41E1-A1B3-114B99822EDF}" type="slidenum">
               <a:rPr lang="zh-CN" altLang="en-US" smtClean="0"/>
               <a:t>‹#›</a:t>
             </a:fld>
@@ -1772,7 +1772,7 @@
     </p:spTree>
     <p:extLst>
       <p:ext uri="{BB962C8B-B14F-4D97-AF65-F5344CB8AC3E}">
-        <p14:creationId xmlns:p14="http://schemas.microsoft.com/office/powerpoint/2010/main" val="2927468478"/>
+        <p14:creationId xmlns:p14="http://schemas.microsoft.com/office/powerpoint/2010/main" val="487852091"/>
       </p:ext>
     </p:extLst>
   </p:cSld>
@@ -1814,7 +1814,7 @@
           <a:bodyPr/>
           <a:lstStyle/>
           <a:p>
-            <a:fld id="{BE8087A8-B5D7-4357-AE59-6FD17618C1CA}" type="datetimeFigureOut">
+            <a:fld id="{DFC4F5E7-0A84-4768-8D36-3515A0B8AD04}" type="datetimeFigureOut">
               <a:rPr lang="zh-CN" altLang="en-US" smtClean="0"/>
               <a:t>2026/10/2</a:t>
             </a:fld>
@@ -1856,7 +1856,7 @@
           <a:bodyPr/>
           <a:lstStyle/>
           <a:p>
-            <a:fld id="{BBD35C1D-5E65-4137-BC2C-8F2F549B8297}" type="slidenum">
+            <a:fld id="{72EA7FEF-5E76-41E1-A1B3-114B99822EDF}" type="slidenum">
               <a:rPr lang="zh-CN" altLang="en-US" smtClean="0"/>
               <a:t>‹#›</a:t>
             </a:fld>
@@ -1867,7 +1867,7 @@
     </p:spTree>
     <p:extLst>
       <p:ext uri="{BB962C8B-B14F-4D97-AF65-F5344CB8AC3E}">
-        <p14:creationId xmlns:p14="http://schemas.microsoft.com/office/powerpoint/2010/main" val="3577161591"/>
+        <p14:creationId xmlns:p14="http://schemas.microsoft.com/office/powerpoint/2010/main" val="2730406071"/>
       </p:ext>
     </p:extLst>
   </p:cSld>
@@ -2091,7 +2091,7 @@
           <a:bodyPr/>
           <a:lstStyle/>
           <a:p>
-            <a:fld id="{BE8087A8-B5D7-4357-AE59-6FD17618C1CA}" type="datetimeFigureOut">
+            <a:fld id="{DFC4F5E7-0A84-4768-8D36-3515A0B8AD04}" type="datetimeFigureOut">
               <a:rPr lang="zh-CN" altLang="en-US" smtClean="0"/>
               <a:t>2026/10/2</a:t>
             </a:fld>
@@ -2133,7 +2133,7 @@
           <a:bodyPr/>
           <a:lstStyle/>
           <a:p>
-            <a:fld id="{BBD35C1D-5E65-4137-BC2C-8F2F549B8297}" type="slidenum">
+            <a:fld id="{72EA7FEF-5E76-41E1-A1B3-114B99822EDF}" type="slidenum">
               <a:rPr lang="zh-CN" altLang="en-US" smtClean="0"/>
               <a:t>‹#›</a:t>
             </a:fld>
@@ -2144,7 +2144,7 @@
     </p:spTree>
     <p:extLst>
       <p:ext uri="{BB962C8B-B14F-4D97-AF65-F5344CB8AC3E}">
-        <p14:creationId xmlns:p14="http://schemas.microsoft.com/office/powerpoint/2010/main" val="475292459"/>
+        <p14:creationId xmlns:p14="http://schemas.microsoft.com/office/powerpoint/2010/main" val="1835329971"/>
       </p:ext>
     </p:extLst>
   </p:cSld>
@@ -2344,7 +2344,7 @@
           <a:bodyPr/>
           <a:lstStyle/>
           <a:p>
-            <a:fld id="{BE8087A8-B5D7-4357-AE59-6FD17618C1CA}" type="datetimeFigureOut">
+            <a:fld id="{DFC4F5E7-0A84-4768-8D36-3515A0B8AD04}" type="datetimeFigureOut">
               <a:rPr lang="zh-CN" altLang="en-US" smtClean="0"/>
               <a:t>2026/10/2</a:t>
             </a:fld>
@@ -2386,7 +2386,7 @@
           <a:bodyPr/>
           <a:lstStyle/>
           <a:p>
-            <a:fld id="{BBD35C1D-5E65-4137-BC2C-8F2F549B8297}" type="slidenum">
+            <a:fld id="{72EA7FEF-5E76-41E1-A1B3-114B99822EDF}" type="slidenum">
               <a:rPr lang="zh-CN" altLang="en-US" smtClean="0"/>
               <a:t>‹#›</a:t>
             </a:fld>
@@ -2397,7 +2397,7 @@
     </p:spTree>
     <p:extLst>
       <p:ext uri="{BB962C8B-B14F-4D97-AF65-F5344CB8AC3E}">
-        <p14:creationId xmlns:p14="http://schemas.microsoft.com/office/powerpoint/2010/main" val="3890189469"/>
+        <p14:creationId xmlns:p14="http://schemas.microsoft.com/office/powerpoint/2010/main" val="2756762200"/>
       </p:ext>
     </p:extLst>
   </p:cSld>
@@ -2557,7 +2557,7 @@
             </a:lvl1pPr>
           </a:lstStyle>
           <a:p>
-            <a:fld id="{BE8087A8-B5D7-4357-AE59-6FD17618C1CA}" type="datetimeFigureOut">
+            <a:fld id="{DFC4F5E7-0A84-4768-8D36-3515A0B8AD04}" type="datetimeFigureOut">
               <a:rPr lang="zh-CN" altLang="en-US" smtClean="0"/>
               <a:t>2026/10/2</a:t>
             </a:fld>
@@ -2635,7 +2635,7 @@
             </a:lvl1pPr>
           </a:lstStyle>
           <a:p>
-            <a:fld id="{BBD35C1D-5E65-4137-BC2C-8F2F549B8297}" type="slidenum">
+            <a:fld id="{72EA7FEF-5E76-41E1-A1B3-114B99822EDF}" type="slidenum">
               <a:rPr lang="zh-CN" altLang="en-US" smtClean="0"/>
               <a:t>‹#›</a:t>
             </a:fld>
@@ -2646,7 +2646,7 @@
     </p:spTree>
     <p:extLst>
       <p:ext uri="{BB962C8B-B14F-4D97-AF65-F5344CB8AC3E}">
-        <p14:creationId xmlns:p14="http://schemas.microsoft.com/office/powerpoint/2010/main" val="433720497"/>
+        <p14:creationId xmlns:p14="http://schemas.microsoft.com/office/powerpoint/2010/main" val="4065311071"/>
       </p:ext>
     </p:extLst>
   </p:cSld>
@@ -3007,10 +3007,570 @@
           </a:p>
         </p:txBody>
       </p:sp>
+      <p:sp>
+        <p:nvSpPr>
+          <p:cNvPr id="3" name="cell0"/>
+          <p:cNvSpPr/>
+          <p:nvPr/>
+        </p:nvSpPr>
+        <p:spPr>
+          <a:xfrm>
+            <a:off x="635000" y="635000"/>
+            <a:ext cx="1270000" cy="1016000"/>
+          </a:xfrm>
+          <a:prstGeom prst="ellipse">
+            <a:avLst/>
+          </a:prstGeom>
+          <a:gradFill flip="none" rotWithShape="1">
+            <a:gsLst>
+              <a:gs pos="0">
+                <a:srgbClr val="FFF2CC"/>
+              </a:gs>
+              <a:gs pos="100000">
+                <a:srgbClr val="512173"/>
+              </a:gs>
+              <a:gs pos="40000">
+                <a:srgbClr val="A65BC4">
+                  <a:alpha val="80000"/>
+                </a:srgbClr>
+              </a:gs>
+            </a:gsLst>
+            <a:lin ang="2100000" scaled="1"/>
+            <a:tileRect/>
+          </a:gradFill>
+          <a:ln w="25400" cap="flat" cmpd="sng" algn="ctr">
+            <a:noFill/>
+            <a:prstDash val="solid"/>
+            <a:miter lim="800000"/>
+          </a:ln>
+          <a:effectLst/>
+          <a:extLst>
+            <a:ext uri="{91240B29-F687-4F45-9708-019B960494DF}">
+              <a14:hiddenLine xmlns:a14="http://schemas.microsoft.com/office/drawing/2010/main" w="25400" cap="flat" cmpd="sng" algn="ctr">
+                <a:solidFill>
+                  <a:srgbClr val="334455"/>
+                </a:solidFill>
+                <a:prstDash val="solid"/>
+                <a:miter lim="800000"/>
+              </a14:hiddenLine>
+            </a:ext>
+          </a:extLst>
+        </p:spPr>
+        <p:style>
+          <a:lnRef idx="2">
+            <a:schemeClr val="accent1">
+              <a:shade val="50000"/>
+            </a:schemeClr>
+          </a:lnRef>
+          <a:fillRef idx="1">
+            <a:schemeClr val="accent1"/>
+          </a:fillRef>
+          <a:effectRef idx="0">
+            <a:schemeClr val="accent1"/>
+          </a:effectRef>
+          <a:fontRef idx="minor">
+            <a:schemeClr val="lt1"/>
+          </a:fontRef>
+        </p:style>
+        <p:txBody>
+          <a:bodyPr rtlCol="0" anchor="ctr"/>
+          <a:lstStyle/>
+          <a:p>
+            <a:pPr algn="ctr"/>
+            <a:endParaRPr lang="zh-CN" altLang="en-US"/>
+          </a:p>
+        </p:txBody>
+      </p:sp>
+      <p:sp>
+        <p:nvSpPr>
+          <p:cNvPr id="4" name="cell1"/>
+          <p:cNvSpPr/>
+          <p:nvPr/>
+        </p:nvSpPr>
+        <p:spPr>
+          <a:xfrm>
+            <a:off x="2286000" y="635000"/>
+            <a:ext cx="1270000" cy="1016000"/>
+          </a:xfrm>
+          <a:prstGeom prst="ellipse">
+            <a:avLst/>
+          </a:prstGeom>
+          <a:gradFill flip="none" rotWithShape="1">
+            <a:gsLst>
+              <a:gs pos="0">
+                <a:srgbClr val="FFF2CC"/>
+              </a:gs>
+              <a:gs pos="100000">
+                <a:srgbClr val="512173"/>
+              </a:gs>
+              <a:gs pos="40000">
+                <a:srgbClr val="A65BC4">
+                  <a:alpha val="80000"/>
+                </a:srgbClr>
+              </a:gs>
+            </a:gsLst>
+            <a:path path="rect">
+              <a:fillToRect l="50000" t="50000" r="50000" b="50000"/>
+            </a:path>
+            <a:tileRect/>
+          </a:gradFill>
+          <a:ln w="12700" cap="flat" cmpd="sng" algn="ctr">
+            <a:noFill/>
+            <a:prstDash val="solid"/>
+            <a:miter lim="800000"/>
+          </a:ln>
+          <a:effectLst/>
+          <a:extLst>
+            <a:ext uri="{91240B29-F687-4F45-9708-019B960494DF}">
+              <a14:hiddenLine xmlns:a14="http://schemas.microsoft.com/office/drawing/2010/main" w="12700" cap="flat" cmpd="sng" algn="ctr">
+                <a:solidFill>
+                  <a:schemeClr val="accent1">
+                    <a:shade val="50000"/>
+                  </a:schemeClr>
+                </a:solidFill>
+                <a:prstDash val="solid"/>
+                <a:miter lim="800000"/>
+              </a14:hiddenLine>
+            </a:ext>
+          </a:extLst>
+        </p:spPr>
+        <p:style>
+          <a:lnRef idx="2">
+            <a:schemeClr val="accent1">
+              <a:shade val="50000"/>
+            </a:schemeClr>
+          </a:lnRef>
+          <a:fillRef idx="1">
+            <a:schemeClr val="accent1"/>
+          </a:fillRef>
+          <a:effectRef idx="0">
+            <a:schemeClr val="accent1"/>
+          </a:effectRef>
+          <a:fontRef idx="minor">
+            <a:schemeClr val="lt1"/>
+          </a:fontRef>
+        </p:style>
+        <p:txBody>
+          <a:bodyPr rtlCol="0" anchor="ctr"/>
+          <a:lstStyle/>
+          <a:p>
+            <a:pPr algn="ctr"/>
+            <a:endParaRPr lang="zh-CN" altLang="en-US"/>
+          </a:p>
+        </p:txBody>
+      </p:sp>
+      <p:sp>
+        <p:nvSpPr>
+          <p:cNvPr id="5" name="cell2"/>
+          <p:cNvSpPr/>
+          <p:nvPr/>
+        </p:nvSpPr>
+        <p:spPr>
+          <a:xfrm>
+            <a:off x="3937000" y="635000"/>
+            <a:ext cx="1270000" cy="1016000"/>
+          </a:xfrm>
+          <a:prstGeom prst="ellipse">
+            <a:avLst/>
+          </a:prstGeom>
+          <a:gradFill flip="none" rotWithShape="1">
+            <a:gsLst>
+              <a:gs pos="0">
+                <a:srgbClr val="FFF2CC"/>
+              </a:gs>
+              <a:gs pos="100000">
+                <a:srgbClr val="512173"/>
+              </a:gs>
+              <a:gs pos="40000">
+                <a:srgbClr val="A65BC4">
+                  <a:alpha val="80000"/>
+                </a:srgbClr>
+              </a:gs>
+            </a:gsLst>
+            <a:path path="rect">
+              <a:fillToRect r="100000" b="100000"/>
+            </a:path>
+            <a:tileRect l="-100000" t="-100000"/>
+          </a:gradFill>
+          <a:ln w="12700" cap="flat" cmpd="sng" algn="ctr">
+            <a:noFill/>
+            <a:prstDash val="solid"/>
+            <a:miter lim="800000"/>
+          </a:ln>
+          <a:effectLst/>
+          <a:extLst>
+            <a:ext uri="{91240B29-F687-4F45-9708-019B960494DF}">
+              <a14:hiddenLine xmlns:a14="http://schemas.microsoft.com/office/drawing/2010/main" w="12700" cap="flat" cmpd="sng" algn="ctr">
+                <a:solidFill>
+                  <a:schemeClr val="accent1">
+                    <a:shade val="50000"/>
+                  </a:schemeClr>
+                </a:solidFill>
+                <a:prstDash val="solid"/>
+                <a:miter lim="800000"/>
+              </a14:hiddenLine>
+            </a:ext>
+          </a:extLst>
+        </p:spPr>
+        <p:style>
+          <a:lnRef idx="2">
+            <a:schemeClr val="accent1">
+              <a:shade val="50000"/>
+            </a:schemeClr>
+          </a:lnRef>
+          <a:fillRef idx="1">
+            <a:schemeClr val="accent1"/>
+          </a:fillRef>
+          <a:effectRef idx="0">
+            <a:schemeClr val="accent1"/>
+          </a:effectRef>
+          <a:fontRef idx="minor">
+            <a:schemeClr val="lt1"/>
+          </a:fontRef>
+        </p:style>
+        <p:txBody>
+          <a:bodyPr rtlCol="0" anchor="ctr"/>
+          <a:lstStyle/>
+          <a:p>
+            <a:pPr algn="ctr"/>
+            <a:endParaRPr lang="zh-CN" altLang="en-US"/>
+          </a:p>
+        </p:txBody>
+      </p:sp>
+      <p:sp>
+        <p:nvSpPr>
+          <p:cNvPr id="9" name="curve"/>
+          <p:cNvSpPr/>
+          <p:nvPr/>
+        </p:nvSpPr>
+        <p:spPr>
+          <a:xfrm>
+            <a:off x="762000" y="3175000"/>
+            <a:ext cx="3175000" cy="508000"/>
+          </a:xfrm>
+          <a:custGeom>
+            <a:avLst/>
+            <a:gdLst>
+              <a:gd name="connsiteX0" fmla="*/ 0 w 3175000"/>
+              <a:gd name="connsiteY0" fmla="*/ 381000 h 508000"/>
+              <a:gd name="connsiteX1" fmla="*/ 2540000 w 3175000"/>
+              <a:gd name="connsiteY1" fmla="*/ 0 h 508000"/>
+              <a:gd name="connsiteX2" fmla="*/ 3175000 w 3175000"/>
+              <a:gd name="connsiteY2" fmla="*/ 508000 h 508000"/>
+              <a:gd name="connsiteX0" fmla="*/ 0 w 3556000"/>
+              <a:gd name="connsiteY0" fmla="*/ 381000 h 508000"/>
+              <a:gd name="connsiteX1" fmla="*/ 2540000 w 3556000"/>
+              <a:gd name="connsiteY1" fmla="*/ 0 h 508000"/>
+              <a:gd name="connsiteX2" fmla="*/ 3175000 w 3556000"/>
+              <a:gd name="connsiteY2" fmla="*/ 508000 h 508000"/>
+              <a:gd name="connsiteX3" fmla="*/ 3556000 w 3556000"/>
+              <a:gd name="connsiteY3" fmla="*/ 0 h 508000"/>
+              <a:gd name="connsiteX0" fmla="*/ 0 w 3175000"/>
+              <a:gd name="connsiteY0" fmla="*/ 381000 h 508000"/>
+              <a:gd name="connsiteX1" fmla="*/ 2540000 w 3175000"/>
+              <a:gd name="connsiteY1" fmla="*/ 0 h 508000"/>
+              <a:gd name="connsiteX2" fmla="*/ 3175000 w 3175000"/>
+              <a:gd name="connsiteY2" fmla="*/ 508000 h 508000"/>
+              <a:gd name="connsiteX0" fmla="*/ 0 w 3175000"/>
+              <a:gd name="connsiteY0" fmla="*/ 381000 h 508000"/>
+              <a:gd name="connsiteX1" fmla="*/ 2540000 w 3175000"/>
+              <a:gd name="connsiteY1" fmla="*/ 0 h 508000"/>
+              <a:gd name="connsiteX2" fmla="*/ 3175000 w 3175000"/>
+              <a:gd name="connsiteY2" fmla="*/ 508000 h 508000"/>
+            </a:gdLst>
+            <a:ahLst/>
+            <a:cxnLst>
+              <a:cxn ang="0">
+                <a:pos x="connsiteX0" y="connsiteY0"/>
+              </a:cxn>
+              <a:cxn ang="0">
+                <a:pos x="connsiteX1" y="connsiteY1"/>
+              </a:cxn>
+              <a:cxn ang="0">
+                <a:pos x="connsiteX2" y="connsiteY2"/>
+              </a:cxn>
+            </a:cxnLst>
+            <a:rect l="l" t="t" r="r" b="b"/>
+            <a:pathLst>
+              <a:path w="3175000" h="508000">
+                <a:moveTo>
+                  <a:pt x="0" y="381000"/>
+                </a:moveTo>
+                <a:cubicBezTo>
+                  <a:pt x="635000" y="-762000"/>
+                  <a:pt x="1905000" y="1270000"/>
+                  <a:pt x="2540000" y="0"/>
+                </a:cubicBezTo>
+                <a:lnTo>
+                  <a:pt x="3175000" y="508000"/>
+                </a:lnTo>
+              </a:path>
+            </a:pathLst>
+          </a:custGeom>
+          <a:ln w="50800">
+            <a:solidFill>
+              <a:srgbClr val="7030A0"/>
+            </a:solidFill>
+          </a:ln>
+        </p:spPr>
+        <p:style>
+          <a:lnRef idx="1">
+            <a:schemeClr val="accent1"/>
+          </a:lnRef>
+          <a:fillRef idx="0">
+            <a:schemeClr val="accent1"/>
+          </a:fillRef>
+          <a:effectRef idx="0">
+            <a:schemeClr val="accent1"/>
+          </a:effectRef>
+          <a:fontRef idx="minor">
+            <a:schemeClr val="tx1"/>
+          </a:fontRef>
+        </p:style>
+        <p:txBody>
+          <a:bodyPr rtlCol="0" anchor="ctr"/>
+          <a:lstStyle/>
+          <a:p>
+            <a:pPr algn="ctr"/>
+            <a:endParaRPr lang="zh-CN" altLang="en-US"/>
+          </a:p>
+        </p:txBody>
+      </p:sp>
+      <p:sp>
+        <p:nvSpPr>
+          <p:cNvPr id="10" name="convert_path"/>
+          <p:cNvSpPr/>
+          <p:nvPr/>
+        </p:nvSpPr>
+        <p:spPr>
+          <a:xfrm>
+            <a:off x="5080000" y="2921000"/>
+            <a:ext cx="1524000" cy="381000"/>
+          </a:xfrm>
+          <a:custGeom>
+            <a:avLst/>
+            <a:gdLst>
+              <a:gd name="connsiteX0" fmla="*/ 0 w 1524000"/>
+              <a:gd name="connsiteY0" fmla="*/ 0 h 381000"/>
+              <a:gd name="connsiteX1" fmla="*/ 762000 w 1524000"/>
+              <a:gd name="connsiteY1" fmla="*/ 381000 h 381000"/>
+              <a:gd name="connsiteX2" fmla="*/ 1524000 w 1524000"/>
+              <a:gd name="connsiteY2" fmla="*/ 0 h 381000"/>
+            </a:gdLst>
+            <a:ahLst/>
+            <a:cxnLst>
+              <a:cxn ang="0">
+                <a:pos x="connsiteX0" y="connsiteY0"/>
+              </a:cxn>
+              <a:cxn ang="0">
+                <a:pos x="connsiteX1" y="connsiteY1"/>
+              </a:cxn>
+              <a:cxn ang="0">
+                <a:pos x="connsiteX2" y="connsiteY2"/>
+              </a:cxn>
+            </a:cxnLst>
+            <a:rect l="l" t="t" r="r" b="b"/>
+            <a:pathLst>
+              <a:path w="1524000" h="381000">
+                <a:moveTo>
+                  <a:pt x="0" y="0"/>
+                </a:moveTo>
+                <a:cubicBezTo>
+                  <a:pt x="254000" y="127000"/>
+                  <a:pt x="508000" y="254000"/>
+                  <a:pt x="762000" y="381000"/>
+                </a:cubicBezTo>
+                <a:lnTo>
+                  <a:pt x="1524000" y="0"/>
+                </a:lnTo>
+              </a:path>
+            </a:pathLst>
+          </a:custGeom>
+          <a:ln w="38100">
+            <a:solidFill>
+              <a:srgbClr val="3388AA"/>
+            </a:solidFill>
+          </a:ln>
+        </p:spPr>
+        <p:style>
+          <a:lnRef idx="1">
+            <a:schemeClr val="accent1"/>
+          </a:lnRef>
+          <a:fillRef idx="0">
+            <a:schemeClr val="accent1"/>
+          </a:fillRef>
+          <a:effectRef idx="0">
+            <a:schemeClr val="accent1"/>
+          </a:effectRef>
+          <a:fontRef idx="minor">
+            <a:schemeClr val="tx1"/>
+          </a:fontRef>
+        </p:style>
+        <p:txBody>
+          <a:bodyPr rtlCol="0" anchor="ctr"/>
+          <a:lstStyle/>
+          <a:p>
+            <a:pPr algn="ctr"/>
+            <a:endParaRPr lang="zh-CN" altLang="en-US"/>
+          </a:p>
+        </p:txBody>
+      </p:sp>
+      <p:sp>
+        <p:nvSpPr>
+          <p:cNvPr id="11" name="label"/>
+          <p:cNvSpPr txBox="1"/>
+          <p:nvPr/>
+        </p:nvSpPr>
+        <p:spPr>
+          <a:xfrm>
+            <a:off x="635000" y="4445000"/>
+            <a:ext cx="10033000" cy="964367"/>
+          </a:xfrm>
+          <a:prstGeom prst="rect">
+            <a:avLst/>
+          </a:prstGeom>
+          <a:noFill/>
+        </p:spPr>
+        <p:txBody>
+          <a:bodyPr vert="horz" rtlCol="0">
+            <a:spAutoFit/>
+          </a:bodyPr>
+          <a:lstStyle/>
+          <a:p>
+            <a:r>
+              <a:rPr lang="pt-BR" altLang="zh-CN" sz="2600" smtClean="0">
+                <a:solidFill>
+                  <a:srgbClr val="334455"/>
+                </a:solidFill>
+                <a:latin typeface="Arial" panose="020B0604020202020204" pitchFamily="34" charset="0"/>
+                <a:ea typeface="Microsoft YaHei" panose="020B0503020204020204" pitchFamily="34" charset="-122"/>
+              </a:rPr>
+              <a:t>H</a:t>
+            </a:r>
+            <a:r>
+              <a:rPr lang="pt-BR" altLang="zh-CN" sz="2400" baseline="-25000" smtClean="0">
+                <a:solidFill>
+                  <a:srgbClr val="334455"/>
+                </a:solidFill>
+                <a:latin typeface="Arial" panose="020B0604020202020204" pitchFamily="34" charset="0"/>
+                <a:ea typeface="Microsoft YaHei" panose="020B0503020204020204" pitchFamily="34" charset="-122"/>
+              </a:rPr>
+              <a:t>2</a:t>
+            </a:r>
+            <a:r>
+              <a:rPr lang="pt-BR" altLang="zh-CN" sz="2400" smtClean="0">
+                <a:solidFill>
+                  <a:srgbClr val="334455"/>
+                </a:solidFill>
+                <a:latin typeface="Arial" panose="020B0604020202020204" pitchFamily="34" charset="0"/>
+                <a:ea typeface="Microsoft YaHei" panose="020B0503020204020204" pitchFamily="34" charset="-122"/>
+              </a:rPr>
+              <a:t>O  ·  Ca</a:t>
+            </a:r>
+            <a:r>
+              <a:rPr lang="pt-BR" altLang="zh-CN" sz="2400" baseline="30000" smtClean="0">
+                <a:solidFill>
+                  <a:srgbClr val="7030A0"/>
+                </a:solidFill>
+                <a:latin typeface="Arial" panose="020B0604020202020204" pitchFamily="34" charset="0"/>
+                <a:ea typeface="Microsoft YaHei" panose="020B0503020204020204" pitchFamily="34" charset="-122"/>
+              </a:rPr>
+              <a:t>2+</a:t>
+            </a:r>
+            <a:r>
+              <a:rPr lang="pt-BR" altLang="zh-CN" sz="2400" i="1" smtClean="0">
+                <a:solidFill>
+                  <a:srgbClr val="334455"/>
+                </a:solidFill>
+                <a:latin typeface="Arial" panose="020B0604020202020204" pitchFamily="34" charset="0"/>
+                <a:ea typeface="Microsoft YaHei" panose="020B0503020204020204" pitchFamily="34" charset="-122"/>
+              </a:rPr>
+              <a:t>  </a:t>
+            </a:r>
+            <a:r>
+              <a:rPr lang="zh-CN" altLang="pt-BR" sz="2400" i="1" smtClean="0">
+                <a:solidFill>
+                  <a:srgbClr val="334455"/>
+                </a:solidFill>
+                <a:latin typeface="Arial" panose="020B0604020202020204" pitchFamily="34" charset="0"/>
+                <a:ea typeface="Microsoft YaHei" panose="020B0503020204020204" pitchFamily="34" charset="-122"/>
+              </a:rPr>
+              <a:t>🧬 </a:t>
+            </a:r>
+            <a:r>
+              <a:rPr lang="pt-BR" altLang="zh-CN" sz="2400" i="1" smtClean="0">
+                <a:solidFill>
+                  <a:srgbClr val="334455"/>
+                </a:solidFill>
+                <a:latin typeface="Arial" panose="020B0604020202020204" pitchFamily="34" charset="0"/>
+                <a:ea typeface="Microsoft YaHei" panose="020B0503020204020204" pitchFamily="34" charset="-122"/>
+              </a:rPr>
+              <a:t>DNA</a:t>
+            </a:r>
+          </a:p>
+          <a:p>
+            <a:pPr marL="457200" indent="-457200">
+              <a:spcBef>
+                <a:spcPts val="800"/>
+              </a:spcBef>
+              <a:buFont typeface="+mj-lt"/>
+              <a:buAutoNum type="arabicPeriod"/>
+            </a:pPr>
+            <a:r>
+              <a:rPr lang="zh-CN" altLang="pt-BR" sz="2400" smtClean="0">
+                <a:solidFill>
+                  <a:srgbClr val="334455"/>
+                </a:solidFill>
+                <a:latin typeface="Arial" panose="020B0604020202020204" pitchFamily="34" charset="0"/>
+                <a:ea typeface="Microsoft YaHei" panose="020B0503020204020204" pitchFamily="34" charset="-122"/>
+              </a:rPr>
+              <a:t>中文 </a:t>
+            </a:r>
+            <a:r>
+              <a:rPr lang="pt-BR" altLang="zh-CN" sz="2400" smtClean="0">
+                <a:solidFill>
+                  <a:srgbClr val="334455"/>
+                </a:solidFill>
+                <a:latin typeface="Arial" panose="020B0604020202020204" pitchFamily="34" charset="0"/>
+                <a:ea typeface="Microsoft YaHei" panose="020B0503020204020204" pitchFamily="34" charset="-122"/>
+              </a:rPr>
+              <a:t>/ English  </a:t>
+            </a:r>
+            <a:r>
+              <a:rPr lang="pt-BR" altLang="zh-CN" sz="2400" u="sng" smtClean="0">
+                <a:solidFill>
+                  <a:srgbClr val="334455"/>
+                </a:solidFill>
+                <a:latin typeface="Arial" panose="020B0604020202020204" pitchFamily="34" charset="0"/>
+                <a:ea typeface="Microsoft YaHei" panose="020B0503020204020204" pitchFamily="34" charset="-122"/>
+                <a:hlinkClick r:id="rId2"/>
+              </a:rPr>
+              <a:t>link</a:t>
+            </a:r>
+            <a:r>
+              <a:rPr lang="pt-BR" altLang="zh-CN" sz="2400" u="sng" smtClean="0">
+                <a:solidFill>
+                  <a:srgbClr val="334455"/>
+                </a:solidFill>
+                <a:latin typeface="Arial" panose="020B0604020202020204" pitchFamily="34" charset="0"/>
+                <a:ea typeface="Microsoft YaHei" panose="020B0503020204020204" pitchFamily="34" charset="-122"/>
+              </a:rPr>
+              <a:t> ✓</a:t>
+            </a:r>
+            <a:endParaRPr lang="zh-CN" altLang="en-US" sz="2400" i="1" u="sng">
+              <a:solidFill>
+                <a:srgbClr val="007799"/>
+              </a:solidFill>
+              <a:latin typeface="Arial" panose="020B0604020202020204" pitchFamily="34" charset="0"/>
+              <a:ea typeface="Microsoft YaHei" panose="020B0503020204020204" pitchFamily="34" charset="-122"/>
+            </a:endParaRPr>
+          </a:p>
+        </p:txBody>
+      </p:sp>
     </p:spTree>
     <p:extLst>
       <p:ext uri="{BB962C8B-B14F-4D97-AF65-F5344CB8AC3E}">
-        <p14:creationId xmlns:p14="http://schemas.microsoft.com/office/powerpoint/2010/main" val="1156693805"/>
+        <p14:creationId xmlns:p14="http://schemas.microsoft.com/office/powerpoint/2010/main" val="45927537"/>
       </p:ext>
     </p:extLst>
   </p:cSld>

</xml_diff>